<commit_message>
Archivo ppt actualizado pero no acabado
</commit_message>
<xml_diff>
--- a/clases/10/teoria/clase-10.pptx
+++ b/clases/10/teoria/clase-10.pptx
@@ -5,7 +5,7 @@
     <p:sldMasterId id="2147483699" r:id="rId1"/>
   </p:sldMasterIdLst>
   <p:notesMasterIdLst>
-    <p:notesMasterId r:id="rId31"/>
+    <p:notesMasterId r:id="rId38"/>
   </p:notesMasterIdLst>
   <p:sldIdLst>
     <p:sldId id="281" r:id="rId2"/>
@@ -35,8 +35,15 @@
     <p:sldId id="619" r:id="rId26"/>
     <p:sldId id="620" r:id="rId27"/>
     <p:sldId id="621" r:id="rId28"/>
-    <p:sldId id="310" r:id="rId29"/>
-    <p:sldId id="277" r:id="rId30"/>
+    <p:sldId id="623" r:id="rId29"/>
+    <p:sldId id="624" r:id="rId30"/>
+    <p:sldId id="625" r:id="rId31"/>
+    <p:sldId id="626" r:id="rId32"/>
+    <p:sldId id="627" r:id="rId33"/>
+    <p:sldId id="628" r:id="rId34"/>
+    <p:sldId id="310" r:id="rId35"/>
+    <p:sldId id="622" r:id="rId36"/>
+    <p:sldId id="277" r:id="rId37"/>
   </p:sldIdLst>
   <p:sldSz cx="9144000" cy="6858000" type="screen4x3"/>
   <p:notesSz cx="6858000" cy="9144000"/>
@@ -22095,7 +22102,7 @@
       </p:grpSpPr>
       <p:sp>
         <p:nvSpPr>
-          <p:cNvPr id="5" name="Title 4"/>
+          <p:cNvPr id="5" name="4 Título"/>
           <p:cNvSpPr>
             <a:spLocks noGrp="1"/>
           </p:cNvSpPr>
@@ -22105,242 +22112,358 @@
         </p:nvSpPr>
         <p:spPr>
           <a:xfrm>
-            <a:off x="107504" y="23817"/>
-            <a:ext cx="7886700" cy="812895"/>
+            <a:off x="308782" y="116632"/>
+            <a:ext cx="8835218" cy="720452"/>
           </a:xfrm>
         </p:spPr>
         <p:txBody>
           <a:bodyPr>
-            <a:normAutofit/>
+            <a:noAutofit/>
           </a:bodyPr>
           <a:lstStyle/>
           <a:p>
             <a:r>
-              <a:rPr lang="en-US" sz="4000" dirty="0"/>
-              <a:t>Referencias</a:t>
+              <a:rPr lang="es-MX" sz="3600" dirty="0"/>
+              <a:t>Resolución de problemas complejos</a:t>
             </a:r>
           </a:p>
         </p:txBody>
       </p:sp>
       <p:sp>
         <p:nvSpPr>
-          <p:cNvPr id="2" name="Content Placeholder 1"/>
-          <p:cNvSpPr>
-            <a:spLocks noGrp="1"/>
-          </p:cNvSpPr>
-          <p:nvPr>
-            <p:ph idx="1"/>
-          </p:nvPr>
+          <p:cNvPr id="13" name="12 Rectángulo"/>
+          <p:cNvSpPr/>
+          <p:nvPr/>
         </p:nvSpPr>
         <p:spPr>
           <a:xfrm>
-            <a:off x="251520" y="1088740"/>
-            <a:ext cx="8424936" cy="5148572"/>
+            <a:off x="179512" y="839028"/>
+            <a:ext cx="8835218" cy="4985980"/>
           </a:xfrm>
+          <a:prstGeom prst="rect">
+            <a:avLst/>
+          </a:prstGeom>
         </p:spPr>
         <p:txBody>
-          <a:bodyPr>
-            <a:normAutofit fontScale="92500" lnSpcReduction="10000"/>
+          <a:bodyPr wrap="square">
+            <a:spAutoFit/>
           </a:bodyPr>
           <a:lstStyle/>
           <a:p>
-            <a:pPr marL="457200" indent="-457200">
-              <a:buFont typeface="+mj-lt"/>
-              <a:buAutoNum type="arabicPeriod"/>
+            <a:pPr marL="342900" indent="-342900">
+              <a:buFont typeface="Arial" panose="020B0604020202020204" pitchFamily="34" charset="0"/>
+              <a:buChar char="•"/>
             </a:pPr>
             <a:r>
-              <a:rPr lang="es-CO" sz="2000" dirty="0">
-                <a:hlinkClick r:id="rId2"/>
-              </a:rPr>
-              <a:t>https://ellibrodepython.com/</a:t>
-            </a:r>
-            <a:endParaRPr lang="es-CO" sz="2000" dirty="0"/>
-          </a:p>
-          <a:p>
-            <a:pPr marL="457200" indent="-457200">
-              <a:buFont typeface="+mj-lt"/>
-              <a:buAutoNum type="arabicPeriod"/>
+              <a:rPr lang="es-MX" sz="2000" b="1" dirty="0"/>
+              <a:t>¿Y si el problema es grande? ¿Por dónde empiezo?</a:t>
+            </a:r>
+          </a:p>
+          <a:p>
+            <a:pPr marL="342900" indent="-342900">
+              <a:buFont typeface="Arial" panose="020B0604020202020204" pitchFamily="34" charset="0"/>
+              <a:buChar char="•"/>
             </a:pPr>
             <a:r>
-              <a:rPr lang="es-CO" sz="2000" dirty="0">
-                <a:hlinkClick r:id="rId3"/>
-              </a:rPr>
-              <a:t>https://www.w3resource.com/index.php</a:t>
-            </a:r>
-            <a:endParaRPr lang="es-CO" sz="2000" dirty="0"/>
-          </a:p>
-          <a:p>
-            <a:pPr marL="457200" indent="-457200">
-              <a:buFont typeface="+mj-lt"/>
-              <a:buAutoNum type="arabicPeriod"/>
+              <a:rPr lang="es-MX" sz="2000" b="1" dirty="0"/>
+              <a:t>Divide y vencerás</a:t>
+            </a:r>
+            <a:r>
+              <a:rPr lang="es-MX" sz="2000" dirty="0"/>
+              <a:t>: dividir un problema complejo en subproblemas más sencillos, y estos a su vez en otros más simples, hasta que cada uno sea fácil de resolver.</a:t>
+            </a:r>
+          </a:p>
+          <a:p>
+            <a:pPr marL="342900" indent="-342900">
+              <a:buFont typeface="Arial" panose="020B0604020202020204" pitchFamily="34" charset="0"/>
+              <a:buChar char="•"/>
             </a:pPr>
             <a:r>
-              <a:rPr lang="es-CO" sz="2000" dirty="0">
+              <a:rPr lang="es-MX" sz="2000" b="1" dirty="0"/>
+              <a:t>Diseño top-</a:t>
+            </a:r>
+            <a:r>
+              <a:rPr lang="es-MX" sz="2000" b="1" dirty="0" err="1"/>
+              <a:t>down</a:t>
+            </a:r>
+            <a:r>
+              <a:rPr lang="es-MX" sz="2000" b="1" dirty="0"/>
+              <a:t> (descendente)</a:t>
+            </a:r>
+            <a:r>
+              <a:rPr lang="es-MX" sz="2000" dirty="0"/>
+              <a:t>: se parte del problema completo (arriba) y se baja, nivel por nivel, hasta las piezas más pequeñas.</a:t>
+            </a:r>
+          </a:p>
+          <a:p>
+            <a:pPr marL="342900" indent="-342900">
+              <a:buFont typeface="Arial" panose="020B0604020202020204" pitchFamily="34" charset="0"/>
+              <a:buChar char="•"/>
+            </a:pPr>
+            <a:endParaRPr lang="es-MX" sz="2000" dirty="0"/>
+          </a:p>
+          <a:p>
+            <a:pPr marL="342900" indent="-342900">
+              <a:buFont typeface="Arial" panose="020B0604020202020204" pitchFamily="34" charset="0"/>
+              <a:buChar char="•"/>
+            </a:pPr>
+            <a:endParaRPr lang="es-MX" sz="2000" dirty="0"/>
+          </a:p>
+          <a:p>
+            <a:pPr marL="342900" indent="-342900">
+              <a:buFont typeface="Arial" panose="020B0604020202020204" pitchFamily="34" charset="0"/>
+              <a:buChar char="•"/>
+            </a:pPr>
+            <a:endParaRPr lang="es-MX" sz="2000" dirty="0"/>
+          </a:p>
+          <a:p>
+            <a:pPr marL="342900" indent="-342900">
+              <a:buFont typeface="Arial" panose="020B0604020202020204" pitchFamily="34" charset="0"/>
+              <a:buChar char="•"/>
+            </a:pPr>
+            <a:endParaRPr lang="es-MX" sz="2000" dirty="0"/>
+          </a:p>
+          <a:p>
+            <a:pPr marL="342900" indent="-342900">
+              <a:buFont typeface="Arial" panose="020B0604020202020204" pitchFamily="34" charset="0"/>
+              <a:buChar char="•"/>
+            </a:pPr>
+            <a:endParaRPr lang="es-MX" sz="2000" dirty="0"/>
+          </a:p>
+          <a:p>
+            <a:pPr marL="342900" indent="-342900">
+              <a:buFont typeface="Arial" panose="020B0604020202020204" pitchFamily="34" charset="0"/>
+              <a:buChar char="•"/>
+            </a:pPr>
+            <a:endParaRPr lang="es-MX" sz="2000" dirty="0"/>
+          </a:p>
+          <a:p>
+            <a:pPr marL="342900" indent="-342900">
+              <a:buFont typeface="Arial" panose="020B0604020202020204" pitchFamily="34" charset="0"/>
+              <a:buChar char="•"/>
+            </a:pPr>
+            <a:endParaRPr lang="es-MX" sz="2000" dirty="0"/>
+          </a:p>
+          <a:p>
+            <a:pPr marL="342900" indent="-342900">
+              <a:buFont typeface="Arial" panose="020B0604020202020204" pitchFamily="34" charset="0"/>
+              <a:buChar char="•"/>
+            </a:pPr>
+            <a:endParaRPr lang="es-MX" sz="2000" dirty="0"/>
+          </a:p>
+          <a:p>
+            <a:pPr marL="342900" indent="-342900">
+              <a:buFont typeface="Arial" panose="020B0604020202020204" pitchFamily="34" charset="0"/>
+              <a:buChar char="•"/>
+            </a:pPr>
+            <a:endParaRPr lang="es-MX" sz="2000" dirty="0"/>
+          </a:p>
+          <a:p>
+            <a:pPr marL="342900" indent="-342900">
+              <a:buFont typeface="Arial" panose="020B0604020202020204" pitchFamily="34" charset="0"/>
+              <a:buChar char="•"/>
+            </a:pPr>
+            <a:endParaRPr lang="es-MX" dirty="0"/>
+          </a:p>
+        </p:txBody>
+      </p:sp>
+      <p:pic>
+        <p:nvPicPr>
+          <p:cNvPr id="6" name="Picture 2" descr="esquema top-down">
+            <a:extLst>
+              <a:ext uri="{FF2B5EF4-FFF2-40B4-BE49-F238E27FC236}">
+                <a16:creationId xmlns:a16="http://schemas.microsoft.com/office/drawing/2014/main" id="{69BCE1C3-120F-4720-8A26-46A22ABB1E89}"/>
+              </a:ext>
+            </a:extLst>
+          </p:cNvPr>
+          <p:cNvPicPr>
+            <a:picLocks noChangeAspect="1" noChangeArrowheads="1"/>
+          </p:cNvPicPr>
+          <p:nvPr/>
+        </p:nvPicPr>
+        <p:blipFill>
+          <a:blip r:embed="rId2">
+            <a:extLst>
+              <a:ext uri="{28A0092B-C50C-407E-A947-70E740481C1C}">
+                <a14:useLocalDpi xmlns:a14="http://schemas.microsoft.com/office/drawing/2010/main" val="0"/>
+              </a:ext>
+            </a:extLst>
+          </a:blip>
+          <a:srcRect/>
+          <a:stretch>
+            <a:fillRect/>
+          </a:stretch>
+        </p:blipFill>
+        <p:spPr bwMode="auto">
+          <a:xfrm>
+            <a:off x="961907" y="3222381"/>
+            <a:ext cx="7858565" cy="2438867"/>
+          </a:xfrm>
+          <a:prstGeom prst="rect">
+            <a:avLst/>
+          </a:prstGeom>
+          <a:noFill/>
+          <a:extLst>
+            <a:ext uri="{909E8E84-426E-40DD-AFC4-6F175D3DCCD1}">
+              <a14:hiddenFill xmlns:a14="http://schemas.microsoft.com/office/drawing/2010/main">
+                <a:solidFill>
+                  <a:srgbClr val="FFFFFF"/>
+                </a:solidFill>
+              </a14:hiddenFill>
+            </a:ext>
+          </a:extLst>
+        </p:spPr>
+      </p:pic>
+      <p:pic>
+        <p:nvPicPr>
+          <p:cNvPr id="7" name="Picture 1">
+            <a:extLst>
+              <a:ext uri="{FF2B5EF4-FFF2-40B4-BE49-F238E27FC236}">
+                <a16:creationId xmlns:a16="http://schemas.microsoft.com/office/drawing/2014/main" id="{4093F735-9854-4635-94C0-9D1BF029EA76}"/>
+              </a:ext>
+            </a:extLst>
+          </p:cNvPr>
+          <p:cNvPicPr>
+            <a:picLocks noChangeAspect="1" noChangeArrowheads="1"/>
+          </p:cNvPicPr>
+          <p:nvPr/>
+        </p:nvPicPr>
+        <p:blipFill>
+          <a:blip r:embed="rId3">
+            <a:extLst>
+              <a:ext uri="{28A0092B-C50C-407E-A947-70E740481C1C}">
+                <a14:useLocalDpi xmlns:a14="http://schemas.microsoft.com/office/drawing/2010/main" val="0"/>
+              </a:ext>
+            </a:extLst>
+          </a:blip>
+          <a:srcRect/>
+          <a:stretch>
+            <a:fillRect/>
+          </a:stretch>
+        </p:blipFill>
+        <p:spPr bwMode="auto">
+          <a:xfrm>
+            <a:off x="594131" y="3039341"/>
+            <a:ext cx="1961645" cy="1613795"/>
+          </a:xfrm>
+          <a:prstGeom prst="rect">
+            <a:avLst/>
+          </a:prstGeom>
+          <a:noFill/>
+          <a:ln>
+            <a:noFill/>
+          </a:ln>
+          <a:extLst>
+            <a:ext uri="{909E8E84-426E-40DD-AFC4-6F175D3DCCD1}">
+              <a14:hiddenFill xmlns:a14="http://schemas.microsoft.com/office/drawing/2010/main">
+                <a:solidFill>
+                  <a:schemeClr val="accent1"/>
+                </a:solidFill>
+              </a14:hiddenFill>
+            </a:ext>
+            <a:ext uri="{91240B29-F687-4F45-9708-019B960494DF}">
+              <a14:hiddenLine xmlns:a14="http://schemas.microsoft.com/office/drawing/2010/main" w="9525">
+                <a:solidFill>
+                  <a:schemeClr val="tx1"/>
+                </a:solidFill>
+                <a:miter lim="800000"/>
+                <a:headEnd/>
+                <a:tailEnd/>
+              </a14:hiddenLine>
+            </a:ext>
+          </a:extLst>
+        </p:spPr>
+      </p:pic>
+      <p:sp>
+        <p:nvSpPr>
+          <p:cNvPr id="10" name="CuadroTexto 9">
+            <a:extLst>
+              <a:ext uri="{FF2B5EF4-FFF2-40B4-BE49-F238E27FC236}">
+                <a16:creationId xmlns:a16="http://schemas.microsoft.com/office/drawing/2014/main" id="{B673CC65-DEEB-4F99-925B-E7F47922A62E}"/>
+              </a:ext>
+            </a:extLst>
+          </p:cNvPr>
+          <p:cNvSpPr txBox="1"/>
+          <p:nvPr/>
+        </p:nvSpPr>
+        <p:spPr>
+          <a:xfrm>
+            <a:off x="251520" y="6309320"/>
+            <a:ext cx="8695542" cy="369332"/>
+          </a:xfrm>
+          <a:prstGeom prst="rect">
+            <a:avLst/>
+          </a:prstGeom>
+          <a:solidFill>
+            <a:schemeClr val="accent2">
+              <a:lumMod val="20000"/>
+              <a:lumOff val="80000"/>
+            </a:schemeClr>
+          </a:solidFill>
+        </p:spPr>
+        <p:txBody>
+          <a:bodyPr wrap="square">
+            <a:spAutoFit/>
+          </a:bodyPr>
+          <a:lstStyle/>
+          <a:p>
+            <a:r>
+              <a:rPr lang="es-CO" b="1" dirty="0"/>
+              <a:t>Idea clave</a:t>
+            </a:r>
+            <a:r>
+              <a:rPr lang="es-CO" dirty="0"/>
+              <a:t>: no se resuelve el problema grande. Se resuelven muchos problemas pequeños.</a:t>
+            </a:r>
+          </a:p>
+        </p:txBody>
+      </p:sp>
+      <p:sp>
+        <p:nvSpPr>
+          <p:cNvPr id="11" name="CuadroTexto 10">
+            <a:extLst>
+              <a:ext uri="{FF2B5EF4-FFF2-40B4-BE49-F238E27FC236}">
+                <a16:creationId xmlns:a16="http://schemas.microsoft.com/office/drawing/2014/main" id="{1D8D8314-2095-4265-8B03-89DB2BAF2078}"/>
+              </a:ext>
+            </a:extLst>
+          </p:cNvPr>
+          <p:cNvSpPr txBox="1"/>
+          <p:nvPr/>
+        </p:nvSpPr>
+        <p:spPr>
+          <a:xfrm>
+            <a:off x="2311121" y="5682734"/>
+            <a:ext cx="4572000" cy="307777"/>
+          </a:xfrm>
+          <a:prstGeom prst="rect">
+            <a:avLst/>
+          </a:prstGeom>
+          <a:noFill/>
+        </p:spPr>
+        <p:txBody>
+          <a:bodyPr wrap="square">
+            <a:spAutoFit/>
+          </a:bodyPr>
+          <a:lstStyle/>
+          <a:p>
+            <a:pPr algn="ctr"/>
+            <a:r>
+              <a:rPr lang="es-CO" sz="1400" b="1" dirty="0"/>
+              <a:t>Diseño Top-Down para conquistar las Galias</a:t>
+            </a:r>
+            <a:r>
+              <a:rPr lang="es-CO" sz="1400" dirty="0"/>
+              <a:t> (</a:t>
+            </a:r>
+            <a:r>
+              <a:rPr lang="es-CO" sz="1400" dirty="0">
                 <a:hlinkClick r:id="rId4"/>
               </a:rPr>
-              <a:t>https://realpython.com/</a:t>
-            </a:r>
-            <a:endParaRPr lang="es-CO" sz="2000" dirty="0"/>
-          </a:p>
-          <a:p>
-            <a:pPr marL="457200" indent="-457200">
-              <a:buFont typeface="+mj-lt"/>
-              <a:buAutoNum type="arabicPeriod"/>
-            </a:pPr>
-            <a:r>
-              <a:rPr lang="es-CO" sz="2000" dirty="0">
-                <a:hlinkClick r:id="rId5"/>
-              </a:rPr>
-              <a:t>https://curriculumresources.edu.gh/wp-content/uploads/2025/01/</a:t>
-            </a:r>
-            <a:endParaRPr lang="es-CO" sz="2000" dirty="0"/>
-          </a:p>
-          <a:p>
-            <a:pPr marL="457200" indent="-457200">
-              <a:buFont typeface="+mj-lt"/>
-              <a:buAutoNum type="arabicPeriod"/>
-            </a:pPr>
-            <a:r>
-              <a:rPr lang="es-CO" sz="2000" dirty="0">
-                <a:hlinkClick r:id="rId6"/>
-              </a:rPr>
-              <a:t>https://python-course.eu/</a:t>
-            </a:r>
-            <a:endParaRPr lang="es-CO" sz="2000" dirty="0"/>
-          </a:p>
-          <a:p>
-            <a:pPr marL="457200" indent="-457200">
-              <a:buFont typeface="+mj-lt"/>
-              <a:buAutoNum type="arabicPeriod"/>
-            </a:pPr>
-            <a:r>
-              <a:rPr lang="es-CO" sz="2000" dirty="0">
-                <a:hlinkClick r:id="rId7"/>
-              </a:rPr>
-              <a:t>https://realpython.com/cheatsheets/python/</a:t>
-            </a:r>
-            <a:endParaRPr lang="es-CO" sz="2000" dirty="0"/>
-          </a:p>
-          <a:p>
-            <a:pPr marL="457200" indent="-457200">
-              <a:buFont typeface="+mj-lt"/>
-              <a:buAutoNum type="arabicPeriod"/>
-            </a:pPr>
-            <a:r>
-              <a:rPr lang="es-CO" sz="2000" dirty="0">
-                <a:hlinkClick r:id="rId8"/>
-              </a:rPr>
-              <a:t>https://realpython.com/defining-your-own-python-function/</a:t>
-            </a:r>
-            <a:r>
-              <a:rPr lang="es-CO" sz="2000" dirty="0"/>
-              <a:t>    </a:t>
-            </a:r>
-          </a:p>
-          <a:p>
-            <a:pPr marL="457200" indent="-457200">
-              <a:buFont typeface="+mj-lt"/>
-              <a:buAutoNum type="arabicPeriod"/>
-            </a:pPr>
-            <a:r>
-              <a:rPr lang="es-CO" sz="2000" dirty="0">
-                <a:hlinkClick r:id="rId9"/>
-              </a:rPr>
-              <a:t>https://realpython.com/python-built-in-functions/</a:t>
-            </a:r>
-            <a:endParaRPr lang="es-CO" sz="2000" dirty="0"/>
-          </a:p>
-          <a:p>
-            <a:pPr marL="457200" indent="-457200">
-              <a:buFont typeface="+mj-lt"/>
-              <a:buAutoNum type="arabicPeriod"/>
-            </a:pPr>
-            <a:r>
-              <a:rPr lang="es-CO" sz="2000" dirty="0">
-                <a:hlinkClick r:id="rId10"/>
-              </a:rPr>
-              <a:t>https://realpython.com/ref/best-practices/functions/</a:t>
-            </a:r>
-            <a:r>
-              <a:rPr lang="es-CO" sz="2000" dirty="0"/>
-              <a:t> </a:t>
-            </a:r>
-          </a:p>
-          <a:p>
-            <a:pPr marL="457200" indent="-457200">
-              <a:buFont typeface="+mj-lt"/>
-              <a:buAutoNum type="arabicPeriod"/>
-            </a:pPr>
-            <a:r>
-              <a:rPr lang="es-CO" sz="2000" dirty="0">
-                <a:hlinkClick r:id="rId11"/>
-              </a:rPr>
-              <a:t>https://makecode.microbit.org/courses/csintro</a:t>
-            </a:r>
-            <a:r>
-              <a:rPr lang="es-CO" sz="2000" dirty="0"/>
-              <a:t>   </a:t>
-            </a:r>
-          </a:p>
-          <a:p>
-            <a:pPr marL="457200" indent="-457200">
-              <a:buFont typeface="+mj-lt"/>
-              <a:buAutoNum type="arabicPeriod"/>
-            </a:pPr>
-            <a:r>
-              <a:rPr lang="en-US" sz="2000" dirty="0">
-                <a:hlinkClick r:id="rId12"/>
-              </a:rPr>
-              <a:t>https://makecode.microbit.org/courses</a:t>
-            </a:r>
-            <a:r>
-              <a:rPr lang="en-US" sz="2000" dirty="0"/>
-              <a:t> </a:t>
-            </a:r>
-          </a:p>
-          <a:p>
-            <a:pPr marL="457200" indent="-457200">
-              <a:buFont typeface="+mj-lt"/>
-              <a:buAutoNum type="arabicPeriod"/>
-            </a:pPr>
-            <a:r>
-              <a:rPr lang="en-US" sz="2000" dirty="0">
-                <a:hlinkClick r:id="rId13"/>
-              </a:rPr>
-              <a:t>https://realpython.com/python-while-loop/</a:t>
-            </a:r>
-            <a:endParaRPr lang="en-US" sz="2000" dirty="0"/>
-          </a:p>
-          <a:p>
-            <a:pPr marL="457200" indent="-457200">
-              <a:buFont typeface="+mj-lt"/>
-              <a:buAutoNum type="arabicPeriod"/>
-            </a:pPr>
-            <a:r>
-              <a:rPr lang="en-US" sz="2000" dirty="0">
-                <a:hlinkClick r:id="rId14"/>
-              </a:rPr>
-              <a:t>https://realpython.com/ref/keywords/while/</a:t>
-            </a:r>
-            <a:r>
-              <a:rPr lang="en-US" sz="2000" dirty="0"/>
-              <a:t> </a:t>
-            </a:r>
-          </a:p>
-          <a:p>
-            <a:pPr marL="457200" indent="-457200">
-              <a:buFont typeface="+mj-lt"/>
-              <a:buAutoNum type="arabicPeriod"/>
-            </a:pPr>
-            <a:r>
-              <a:rPr lang="en-US" sz="2000" dirty="0">
-                <a:hlinkClick r:id="rId15"/>
-              </a:rPr>
-              <a:t>https://cs.stanford.edu/people/nick/py/</a:t>
-            </a:r>
-            <a:r>
-              <a:rPr lang="en-US" sz="2000" dirty="0"/>
-              <a:t> </a:t>
+              <a:t>link</a:t>
+            </a:r>
+            <a:r>
+              <a:rPr lang="es-CO" sz="1400" dirty="0"/>
+              <a:t>).</a:t>
             </a:r>
           </a:p>
         </p:txBody>
@@ -22348,7 +22471,7 @@
     </p:spTree>
     <p:extLst>
       <p:ext uri="{BB962C8B-B14F-4D97-AF65-F5344CB8AC3E}">
-        <p14:creationId xmlns:p14="http://schemas.microsoft.com/office/powerpoint/2010/main" val="1023164851"/>
+        <p14:creationId xmlns:p14="http://schemas.microsoft.com/office/powerpoint/2010/main" val="4073108364"/>
       </p:ext>
     </p:extLst>
   </p:cSld>
@@ -22377,7 +22500,7 @@
       </p:grpSpPr>
       <p:sp>
         <p:nvSpPr>
-          <p:cNvPr id="2" name="Title 1"/>
+          <p:cNvPr id="5" name="4 Título"/>
           <p:cNvSpPr>
             <a:spLocks noGrp="1"/>
           </p:cNvSpPr>
@@ -22387,85 +22510,33 @@
         </p:nvSpPr>
         <p:spPr>
           <a:xfrm>
-            <a:off x="323528" y="180617"/>
-            <a:ext cx="8191822" cy="728103"/>
+            <a:off x="308782" y="116632"/>
+            <a:ext cx="8835218" cy="720452"/>
           </a:xfrm>
         </p:spPr>
         <p:txBody>
-          <a:bodyPr/>
+          <a:bodyPr>
+            <a:noAutofit/>
+          </a:bodyPr>
           <a:lstStyle/>
           <a:p>
             <a:r>
-              <a:rPr lang="es-CO" dirty="0"/>
-              <a:t>Eso es todo amigos</a:t>
-            </a:r>
-            <a:endParaRPr lang="en-US" dirty="0"/>
+              <a:rPr lang="es-MX" sz="3600" dirty="0"/>
+              <a:t>El primer nivel: entrada, proceso y salida</a:t>
+            </a:r>
           </a:p>
         </p:txBody>
       </p:sp>
-      <p:pic>
-        <p:nvPicPr>
-          <p:cNvPr id="4" name="Picture 4">
-            <a:extLst>
-              <a:ext uri="{FF2B5EF4-FFF2-40B4-BE49-F238E27FC236}">
-                <a16:creationId xmlns:a16="http://schemas.microsoft.com/office/drawing/2014/main" id="{7F35EEF4-F126-467F-A5BB-259AA64991BD}"/>
-              </a:ext>
-            </a:extLst>
-          </p:cNvPr>
-          <p:cNvPicPr>
-            <a:picLocks noChangeAspect="1" noChangeArrowheads="1"/>
-          </p:cNvPicPr>
-          <p:nvPr/>
-        </p:nvPicPr>
-        <p:blipFill>
-          <a:blip r:embed="rId2">
-            <a:extLst>
-              <a:ext uri="{28A0092B-C50C-407E-A947-70E740481C1C}">
-                <a14:useLocalDpi xmlns:a14="http://schemas.microsoft.com/office/drawing/2010/main" val="0"/>
-              </a:ext>
-            </a:extLst>
-          </a:blip>
-          <a:srcRect/>
-          <a:stretch>
-            <a:fillRect/>
-          </a:stretch>
-        </p:blipFill>
-        <p:spPr bwMode="auto">
-          <a:xfrm>
-            <a:off x="4211960" y="912200"/>
-            <a:ext cx="4113633" cy="5868856"/>
-          </a:xfrm>
-          <a:prstGeom prst="rect">
-            <a:avLst/>
-          </a:prstGeom>
-          <a:noFill/>
-          <a:extLst>
-            <a:ext uri="{909E8E84-426E-40DD-AFC4-6F175D3DCCD1}">
-              <a14:hiddenFill xmlns:a14="http://schemas.microsoft.com/office/drawing/2010/main">
-                <a:solidFill>
-                  <a:srgbClr val="FFFFFF"/>
-                </a:solidFill>
-              </a14:hiddenFill>
-            </a:ext>
-          </a:extLst>
-        </p:spPr>
-      </p:pic>
       <p:sp>
         <p:nvSpPr>
-          <p:cNvPr id="5" name="7 Rectángulo">
-            <a:extLst>
-              <a:ext uri="{FF2B5EF4-FFF2-40B4-BE49-F238E27FC236}">
-                <a16:creationId xmlns:a16="http://schemas.microsoft.com/office/drawing/2014/main" id="{27C7AA4C-274E-4F17-B614-41C209AA98D3}"/>
-              </a:ext>
-            </a:extLst>
-          </p:cNvPr>
+          <p:cNvPr id="13" name="12 Rectángulo"/>
           <p:cNvSpPr/>
           <p:nvPr/>
         </p:nvSpPr>
         <p:spPr>
           <a:xfrm>
-            <a:off x="101021" y="6519446"/>
-            <a:ext cx="3678892" cy="261610"/>
+            <a:off x="179512" y="717664"/>
+            <a:ext cx="8835218" cy="1631216"/>
           </a:xfrm>
           <a:prstGeom prst="rect">
             <a:avLst/>
@@ -22477,70 +22548,185 @@
           </a:bodyPr>
           <a:lstStyle/>
           <a:p>
-            <a:r>
-              <a:rPr lang="es-CO" sz="1100" dirty="0">
-                <a:hlinkClick r:id="rId3"/>
-              </a:rPr>
-              <a:t>https://phdcomics.com/comics/archive.php?comicid=1431</a:t>
-            </a:r>
-            <a:r>
-              <a:rPr lang="es-CO" sz="1100" dirty="0"/>
-              <a:t> </a:t>
+            <a:pPr marL="342900" indent="-342900" rtl="0">
+              <a:buFont typeface="Arial" panose="020B0604020202020204" pitchFamily="34" charset="0"/>
+              <a:buChar char="•"/>
+            </a:pPr>
+            <a:r>
+              <a:rPr lang="es-MX" sz="2000" dirty="0"/>
+              <a:t>Casi todo programa se divide primero en las mismas tres partes ya vistas: </a:t>
+            </a:r>
+          </a:p>
+          <a:p>
+            <a:pPr rtl="0"/>
+            <a:endParaRPr lang="es-MX" sz="2000" b="1" dirty="0"/>
+          </a:p>
+          <a:p>
+            <a:pPr algn="ctr" rtl="0"/>
+            <a:r>
+              <a:rPr lang="es-MX" sz="2000" b="1" dirty="0"/>
+              <a:t>entrada → proceso → salida</a:t>
+            </a:r>
+            <a:r>
+              <a:rPr lang="es-MX" sz="2000" dirty="0"/>
+              <a:t>.</a:t>
+            </a:r>
+          </a:p>
+          <a:p>
+            <a:pPr algn="ctr" rtl="0"/>
+            <a:endParaRPr lang="es-MX" sz="2000" dirty="0"/>
+          </a:p>
+          <a:p>
+            <a:pPr marL="342900" indent="-342900" rtl="0">
+              <a:buFont typeface="Arial" panose="020B0604020202020204" pitchFamily="34" charset="0"/>
+              <a:buChar char="•"/>
+            </a:pPr>
+            <a:r>
+              <a:rPr lang="es-MX" sz="2000" dirty="0"/>
+              <a:t>El programa de temperaturas ya era </a:t>
+            </a:r>
+            <a:r>
+              <a:rPr lang="es-MX" sz="2000" b="1" dirty="0"/>
+              <a:t>top-</a:t>
+            </a:r>
+            <a:r>
+              <a:rPr lang="es-MX" sz="2000" b="1" dirty="0" err="1"/>
+              <a:t>down</a:t>
+            </a:r>
+            <a:r>
+              <a:rPr lang="es-MX" sz="2000" dirty="0"/>
+              <a:t>:</a:t>
+            </a:r>
+            <a:endParaRPr lang="es-MX" dirty="0"/>
+          </a:p>
+        </p:txBody>
+      </p:sp>
+      <p:sp>
+        <p:nvSpPr>
+          <p:cNvPr id="10" name="CuadroTexto 9">
+            <a:extLst>
+              <a:ext uri="{FF2B5EF4-FFF2-40B4-BE49-F238E27FC236}">
+                <a16:creationId xmlns:a16="http://schemas.microsoft.com/office/drawing/2014/main" id="{B673CC65-DEEB-4F99-925B-E7F47922A62E}"/>
+              </a:ext>
+            </a:extLst>
+          </p:cNvPr>
+          <p:cNvSpPr txBox="1"/>
+          <p:nvPr/>
+        </p:nvSpPr>
+        <p:spPr>
+          <a:xfrm>
+            <a:off x="251520" y="6093296"/>
+            <a:ext cx="8695542" cy="646331"/>
+          </a:xfrm>
+          <a:prstGeom prst="rect">
+            <a:avLst/>
+          </a:prstGeom>
+          <a:solidFill>
+            <a:schemeClr val="accent2">
+              <a:lumMod val="20000"/>
+              <a:lumOff val="80000"/>
+            </a:schemeClr>
+          </a:solidFill>
+        </p:spPr>
+        <p:txBody>
+          <a:bodyPr wrap="square">
+            <a:spAutoFit/>
+          </a:bodyPr>
+          <a:lstStyle/>
+          <a:p>
+            <a:r>
+              <a:rPr lang="es-MX" b="1" dirty="0"/>
+              <a:t>No es un método nuevo: </a:t>
+            </a:r>
+            <a:r>
+              <a:rPr lang="es-MX" dirty="0"/>
+              <a:t>es lo que se hizo previamente con temperaturas. Ahora tiene nombre.</a:t>
             </a:r>
           </a:p>
         </p:txBody>
       </p:sp>
       <p:pic>
         <p:nvPicPr>
-          <p:cNvPr id="2050" name="Picture 2" descr="Ouch Images – Browse 81,244 Stock Photos, Vectors, and Video | Adobe Stock">
+          <p:cNvPr id="3" name="Imagen 2">
             <a:extLst>
               <a:ext uri="{FF2B5EF4-FFF2-40B4-BE49-F238E27FC236}">
-                <a16:creationId xmlns:a16="http://schemas.microsoft.com/office/drawing/2014/main" id="{190AEE93-FCB4-45D0-A740-34697C5E7782}"/>
+                <a16:creationId xmlns:a16="http://schemas.microsoft.com/office/drawing/2014/main" id="{37B98D33-7CCB-41E3-90FC-F4379A9BB1C3}"/>
               </a:ext>
             </a:extLst>
           </p:cNvPr>
           <p:cNvPicPr>
-            <a:picLocks noChangeAspect="1" noChangeArrowheads="1"/>
+            <a:picLocks noChangeAspect="1"/>
           </p:cNvPicPr>
           <p:nvPr/>
         </p:nvPicPr>
         <p:blipFill>
-          <a:blip r:embed="rId4">
-            <a:extLst>
-              <a:ext uri="{28A0092B-C50C-407E-A947-70E740481C1C}">
-                <a14:useLocalDpi xmlns:a14="http://schemas.microsoft.com/office/drawing/2010/main" val="0"/>
-              </a:ext>
-            </a:extLst>
-          </a:blip>
-          <a:srcRect/>
+          <a:blip r:embed="rId2"/>
           <a:stretch>
             <a:fillRect/>
           </a:stretch>
         </p:blipFill>
-        <p:spPr bwMode="auto">
+        <p:spPr>
           <a:xfrm>
-            <a:off x="297451" y="2496793"/>
-            <a:ext cx="3563955" cy="2434580"/>
+            <a:off x="971600" y="2276872"/>
+            <a:ext cx="7200800" cy="3398777"/>
+          </a:xfrm>
+          <a:prstGeom prst="rect">
+            <a:avLst/>
+          </a:prstGeom>
+        </p:spPr>
+      </p:pic>
+      <p:sp>
+        <p:nvSpPr>
+          <p:cNvPr id="14" name="CuadroTexto 13">
+            <a:extLst>
+              <a:ext uri="{FF2B5EF4-FFF2-40B4-BE49-F238E27FC236}">
+                <a16:creationId xmlns:a16="http://schemas.microsoft.com/office/drawing/2014/main" id="{026C3336-30AD-429B-8D85-6797BECC2F78}"/>
+              </a:ext>
+            </a:extLst>
+          </p:cNvPr>
+          <p:cNvSpPr txBox="1"/>
+          <p:nvPr/>
+        </p:nvSpPr>
+        <p:spPr>
+          <a:xfrm>
+            <a:off x="467544" y="5579948"/>
+            <a:ext cx="8407510" cy="369332"/>
           </a:xfrm>
           <a:prstGeom prst="rect">
             <a:avLst/>
           </a:prstGeom>
           <a:noFill/>
-          <a:extLst>
-            <a:ext uri="{909E8E84-426E-40DD-AFC4-6F175D3DCCD1}">
-              <a14:hiddenFill xmlns:a14="http://schemas.microsoft.com/office/drawing/2010/main">
-                <a:solidFill>
-                  <a:srgbClr val="FFFFFF"/>
-                </a:solidFill>
-              </a14:hiddenFill>
-            </a:ext>
-          </a:extLst>
         </p:spPr>
-      </p:pic>
+        <p:txBody>
+          <a:bodyPr wrap="square">
+            <a:spAutoFit/>
+          </a:bodyPr>
+          <a:lstStyle/>
+          <a:p>
+            <a:pPr algn="ctr"/>
+            <a:r>
+              <a:rPr lang="es-CO" b="1" dirty="0"/>
+              <a:t>Diagrama top-</a:t>
+            </a:r>
+            <a:r>
+              <a:rPr lang="es-CO" b="1" dirty="0" err="1"/>
+              <a:t>down</a:t>
+            </a:r>
+            <a:r>
+              <a:rPr lang="es-CO" b="1" dirty="0"/>
+              <a:t> temperaturas</a:t>
+            </a:r>
+            <a:r>
+              <a:rPr lang="es-CO" dirty="0"/>
+              <a:t>: ¿Dónde está cada parte en temperaturas_v2.py?</a:t>
+            </a:r>
+          </a:p>
+        </p:txBody>
+      </p:sp>
     </p:spTree>
     <p:extLst>
       <p:ext uri="{BB962C8B-B14F-4D97-AF65-F5344CB8AC3E}">
-        <p14:creationId xmlns:p14="http://schemas.microsoft.com/office/powerpoint/2010/main" val="3024962735"/>
+        <p14:creationId xmlns:p14="http://schemas.microsoft.com/office/powerpoint/2010/main" val="1069985901"/>
       </p:ext>
     </p:extLst>
   </p:cSld>
@@ -23117,6 +23303,2378 @@
     <p:extLst>
       <p:ext uri="{BB962C8B-B14F-4D97-AF65-F5344CB8AC3E}">
         <p14:creationId xmlns:p14="http://schemas.microsoft.com/office/powerpoint/2010/main" val="106452970"/>
+      </p:ext>
+    </p:extLst>
+  </p:cSld>
+  <p:clrMapOvr>
+    <a:masterClrMapping/>
+  </p:clrMapOvr>
+</p:sld>
+</file>
+
+<file path=ppt/slides/slide30.xml><?xml version="1.0" encoding="utf-8"?>
+<p:sld xmlns:a="http://schemas.openxmlformats.org/drawingml/2006/main" xmlns:r="http://schemas.openxmlformats.org/officeDocument/2006/relationships" xmlns:p="http://schemas.openxmlformats.org/presentationml/2006/main">
+  <p:cSld>
+    <p:spTree>
+      <p:nvGrpSpPr>
+        <p:cNvPr id="1" name=""/>
+        <p:cNvGrpSpPr/>
+        <p:nvPr/>
+      </p:nvGrpSpPr>
+      <p:grpSpPr>
+        <a:xfrm>
+          <a:off x="0" y="0"/>
+          <a:ext cx="0" cy="0"/>
+          <a:chOff x="0" y="0"/>
+          <a:chExt cx="0" cy="0"/>
+        </a:xfrm>
+      </p:grpSpPr>
+      <p:sp>
+        <p:nvSpPr>
+          <p:cNvPr id="5" name="4 Título"/>
+          <p:cNvSpPr>
+            <a:spLocks noGrp="1"/>
+          </p:cNvSpPr>
+          <p:nvPr>
+            <p:ph type="title"/>
+          </p:nvPr>
+        </p:nvSpPr>
+        <p:spPr>
+          <a:xfrm>
+            <a:off x="308782" y="116632"/>
+            <a:ext cx="8835218" cy="720452"/>
+          </a:xfrm>
+        </p:spPr>
+        <p:txBody>
+          <a:bodyPr>
+            <a:noAutofit/>
+          </a:bodyPr>
+          <a:lstStyle/>
+          <a:p>
+            <a:r>
+              <a:rPr lang="es-MX" sz="3600" dirty="0"/>
+              <a:t>¿Hasta dónde dividir?</a:t>
+            </a:r>
+          </a:p>
+        </p:txBody>
+      </p:sp>
+      <p:sp>
+        <p:nvSpPr>
+          <p:cNvPr id="13" name="12 Rectángulo"/>
+          <p:cNvSpPr/>
+          <p:nvPr/>
+        </p:nvSpPr>
+        <p:spPr>
+          <a:xfrm>
+            <a:off x="179512" y="717664"/>
+            <a:ext cx="8835218" cy="1323439"/>
+          </a:xfrm>
+          <a:prstGeom prst="rect">
+            <a:avLst/>
+          </a:prstGeom>
+        </p:spPr>
+        <p:txBody>
+          <a:bodyPr wrap="square">
+            <a:spAutoFit/>
+          </a:bodyPr>
+          <a:lstStyle/>
+          <a:p>
+            <a:pPr rtl="0"/>
+            <a:r>
+              <a:rPr lang="es-MX" sz="2000" b="1" dirty="0"/>
+              <a:t>Ejemplo:</a:t>
+            </a:r>
+            <a:r>
+              <a:rPr lang="es-MX" sz="2000" dirty="0"/>
+              <a:t> </a:t>
+            </a:r>
+            <a:r>
+              <a:rPr lang="es-CO" sz="2000" dirty="0"/>
+              <a:t>Hacer un programa que despliegue un calendario para un mes del año dado. El programa solicita al usuario que ingrese el año y el mes, y entonces despliega el calendario entero para ese mes tal y como lo muestra la siguiente figura:</a:t>
+            </a:r>
+            <a:endParaRPr lang="es-MX" sz="2000" dirty="0"/>
+          </a:p>
+        </p:txBody>
+      </p:sp>
+      <p:sp>
+        <p:nvSpPr>
+          <p:cNvPr id="14" name="CuadroTexto 13">
+            <a:extLst>
+              <a:ext uri="{FF2B5EF4-FFF2-40B4-BE49-F238E27FC236}">
+                <a16:creationId xmlns:a16="http://schemas.microsoft.com/office/drawing/2014/main" id="{026C3336-30AD-429B-8D85-6797BECC2F78}"/>
+              </a:ext>
+            </a:extLst>
+          </p:cNvPr>
+          <p:cNvSpPr txBox="1"/>
+          <p:nvPr/>
+        </p:nvSpPr>
+        <p:spPr>
+          <a:xfrm>
+            <a:off x="467544" y="5579948"/>
+            <a:ext cx="8208912" cy="369332"/>
+          </a:xfrm>
+          <a:prstGeom prst="rect">
+            <a:avLst/>
+          </a:prstGeom>
+          <a:solidFill>
+            <a:schemeClr val="accent6">
+              <a:lumMod val="20000"/>
+              <a:lumOff val="80000"/>
+            </a:schemeClr>
+          </a:solidFill>
+        </p:spPr>
+        <p:txBody>
+          <a:bodyPr wrap="square">
+            <a:spAutoFit/>
+          </a:bodyPr>
+          <a:lstStyle/>
+          <a:p>
+            <a:r>
+              <a:rPr lang="es-MX" b="1" dirty="0"/>
+              <a:t>Antes de ver la solución:</a:t>
+            </a:r>
+            <a:r>
+              <a:rPr lang="es-MX" dirty="0"/>
+              <a:t> ¿en qué partes dividirían este problema?</a:t>
+            </a:r>
+            <a:endParaRPr lang="es-CO" dirty="0"/>
+          </a:p>
+        </p:txBody>
+      </p:sp>
+      <p:pic>
+        <p:nvPicPr>
+          <p:cNvPr id="7" name="Picture 2">
+            <a:extLst>
+              <a:ext uri="{FF2B5EF4-FFF2-40B4-BE49-F238E27FC236}">
+                <a16:creationId xmlns:a16="http://schemas.microsoft.com/office/drawing/2014/main" id="{B7DBF9EF-FE6D-4839-85E5-F5EB76D21D87}"/>
+              </a:ext>
+            </a:extLst>
+          </p:cNvPr>
+          <p:cNvPicPr>
+            <a:picLocks noChangeAspect="1" noChangeArrowheads="1"/>
+          </p:cNvPicPr>
+          <p:nvPr/>
+        </p:nvPicPr>
+        <p:blipFill>
+          <a:blip r:embed="rId2">
+            <a:extLst>
+              <a:ext uri="{28A0092B-C50C-407E-A947-70E740481C1C}">
+                <a14:useLocalDpi xmlns:a14="http://schemas.microsoft.com/office/drawing/2010/main" val="0"/>
+              </a:ext>
+            </a:extLst>
+          </a:blip>
+          <a:srcRect/>
+          <a:stretch>
+            <a:fillRect/>
+          </a:stretch>
+        </p:blipFill>
+        <p:spPr bwMode="auto">
+          <a:xfrm>
+            <a:off x="611560" y="2119746"/>
+            <a:ext cx="8064896" cy="2748625"/>
+          </a:xfrm>
+          <a:prstGeom prst="rect">
+            <a:avLst/>
+          </a:prstGeom>
+          <a:noFill/>
+          <a:ln>
+            <a:noFill/>
+          </a:ln>
+          <a:extLst>
+            <a:ext uri="{909E8E84-426E-40DD-AFC4-6F175D3DCCD1}">
+              <a14:hiddenFill xmlns:a14="http://schemas.microsoft.com/office/drawing/2010/main">
+                <a:solidFill>
+                  <a:schemeClr val="accent1"/>
+                </a:solidFill>
+              </a14:hiddenFill>
+            </a:ext>
+            <a:ext uri="{91240B29-F687-4F45-9708-019B960494DF}">
+              <a14:hiddenLine xmlns:a14="http://schemas.microsoft.com/office/drawing/2010/main" w="9525">
+                <a:solidFill>
+                  <a:schemeClr val="tx1"/>
+                </a:solidFill>
+                <a:miter lim="800000"/>
+                <a:headEnd/>
+                <a:tailEnd/>
+              </a14:hiddenLine>
+            </a:ext>
+          </a:extLst>
+        </p:spPr>
+      </p:pic>
+    </p:spTree>
+    <p:extLst>
+      <p:ext uri="{BB962C8B-B14F-4D97-AF65-F5344CB8AC3E}">
+        <p14:creationId xmlns:p14="http://schemas.microsoft.com/office/powerpoint/2010/main" val="749932190"/>
+      </p:ext>
+    </p:extLst>
+  </p:cSld>
+  <p:clrMapOvr>
+    <a:masterClrMapping/>
+  </p:clrMapOvr>
+</p:sld>
+</file>
+
+<file path=ppt/slides/slide31.xml><?xml version="1.0" encoding="utf-8"?>
+<p:sld xmlns:a="http://schemas.openxmlformats.org/drawingml/2006/main" xmlns:r="http://schemas.openxmlformats.org/officeDocument/2006/relationships" xmlns:p="http://schemas.openxmlformats.org/presentationml/2006/main">
+  <p:cSld>
+    <p:spTree>
+      <p:nvGrpSpPr>
+        <p:cNvPr id="1" name=""/>
+        <p:cNvGrpSpPr/>
+        <p:nvPr/>
+      </p:nvGrpSpPr>
+      <p:grpSpPr>
+        <a:xfrm>
+          <a:off x="0" y="0"/>
+          <a:ext cx="0" cy="0"/>
+          <a:chOff x="0" y="0"/>
+          <a:chExt cx="0" cy="0"/>
+        </a:xfrm>
+      </p:grpSpPr>
+      <p:sp>
+        <p:nvSpPr>
+          <p:cNvPr id="5" name="4 Título"/>
+          <p:cNvSpPr>
+            <a:spLocks noGrp="1"/>
+          </p:cNvSpPr>
+          <p:nvPr>
+            <p:ph type="title"/>
+          </p:nvPr>
+        </p:nvSpPr>
+        <p:spPr>
+          <a:xfrm>
+            <a:off x="308782" y="116632"/>
+            <a:ext cx="8835218" cy="720452"/>
+          </a:xfrm>
+        </p:spPr>
+        <p:txBody>
+          <a:bodyPr>
+            <a:noAutofit/>
+          </a:bodyPr>
+          <a:lstStyle/>
+          <a:p>
+            <a:r>
+              <a:rPr lang="es-MX" sz="3600" dirty="0"/>
+              <a:t>¿Hasta dónde dividir?</a:t>
+            </a:r>
+          </a:p>
+        </p:txBody>
+      </p:sp>
+      <p:sp>
+        <p:nvSpPr>
+          <p:cNvPr id="13" name="12 Rectángulo"/>
+          <p:cNvSpPr/>
+          <p:nvPr/>
+        </p:nvSpPr>
+        <p:spPr>
+          <a:xfrm>
+            <a:off x="179512" y="717664"/>
+            <a:ext cx="8835218" cy="1631216"/>
+          </a:xfrm>
+          <a:prstGeom prst="rect">
+            <a:avLst/>
+          </a:prstGeom>
+        </p:spPr>
+        <p:txBody>
+          <a:bodyPr wrap="square">
+            <a:spAutoFit/>
+          </a:bodyPr>
+          <a:lstStyle/>
+          <a:p>
+            <a:pPr rtl="0"/>
+            <a:r>
+              <a:rPr lang="es-CO" sz="2000" b="1" dirty="0"/>
+              <a:t>Diagrama Top-Down</a:t>
+            </a:r>
+            <a:r>
+              <a:rPr lang="es-CO" sz="2000" dirty="0"/>
+              <a:t>:</a:t>
+            </a:r>
+          </a:p>
+          <a:p>
+            <a:pPr marL="342900" indent="-342900" rtl="0">
+              <a:buFont typeface="Arial" panose="020B0604020202020204" pitchFamily="34" charset="0"/>
+              <a:buChar char="•"/>
+            </a:pPr>
+            <a:r>
+              <a:rPr lang="es-MX" sz="2000" dirty="0"/>
+              <a:t>Se divide hasta que cada pieza haga una sola cosa y su nombre lo diga.</a:t>
+            </a:r>
+          </a:p>
+          <a:p>
+            <a:pPr marL="342900" indent="-342900" rtl="0">
+              <a:buFont typeface="Arial" panose="020B0604020202020204" pitchFamily="34" charset="0"/>
+              <a:buChar char="•"/>
+            </a:pPr>
+            <a:r>
+              <a:rPr lang="es-MX" sz="2000" b="1" dirty="0"/>
+              <a:t>Algunas piezas ya son conocidas</a:t>
+            </a:r>
+            <a:r>
+              <a:rPr lang="es-MX" sz="2000" dirty="0"/>
+              <a:t>: </a:t>
+            </a:r>
+            <a:r>
+              <a:rPr lang="es-MX" sz="1600" b="1" dirty="0" err="1">
+                <a:latin typeface="Consolas" panose="020B0609020204030204" pitchFamily="49" charset="0"/>
+              </a:rPr>
+              <a:t>es_bisiesto</a:t>
+            </a:r>
+            <a:r>
+              <a:rPr lang="es-MX" sz="2000" dirty="0"/>
+              <a:t> es el ejemplo de la clase 7.</a:t>
+            </a:r>
+          </a:p>
+          <a:p>
+            <a:pPr marL="342900" indent="-342900" rtl="0">
+              <a:buFont typeface="Arial" panose="020B0604020202020204" pitchFamily="34" charset="0"/>
+              <a:buChar char="•"/>
+            </a:pPr>
+            <a:r>
+              <a:rPr lang="es-MX" sz="2000" b="1" dirty="0"/>
+              <a:t>Una misma función puede ser usada por varias</a:t>
+            </a:r>
+            <a:r>
+              <a:rPr lang="es-MX" sz="2000" dirty="0"/>
+              <a:t>: </a:t>
+            </a:r>
+            <a:r>
+              <a:rPr lang="es-MX" b="1" dirty="0" err="1">
+                <a:latin typeface="Consolas" panose="020B0609020204030204" pitchFamily="49" charset="0"/>
+              </a:rPr>
+              <a:t>obtener_dias_mes</a:t>
+            </a:r>
+            <a:r>
+              <a:rPr lang="es-MX" sz="2000" dirty="0"/>
+              <a:t> aparece en dos ramas. Eso es reutilización.</a:t>
+            </a:r>
+          </a:p>
+        </p:txBody>
+      </p:sp>
+      <p:pic>
+        <p:nvPicPr>
+          <p:cNvPr id="4" name="Imagen 3">
+            <a:extLst>
+              <a:ext uri="{FF2B5EF4-FFF2-40B4-BE49-F238E27FC236}">
+                <a16:creationId xmlns:a16="http://schemas.microsoft.com/office/drawing/2014/main" id="{22855065-2A59-4C93-A3C4-DB0C88805A3D}"/>
+              </a:ext>
+            </a:extLst>
+          </p:cNvPr>
+          <p:cNvPicPr>
+            <a:picLocks noChangeAspect="1"/>
+          </p:cNvPicPr>
+          <p:nvPr/>
+        </p:nvPicPr>
+        <p:blipFill>
+          <a:blip r:embed="rId2"/>
+          <a:stretch>
+            <a:fillRect/>
+          </a:stretch>
+        </p:blipFill>
+        <p:spPr>
+          <a:xfrm>
+            <a:off x="1331641" y="2306216"/>
+            <a:ext cx="6905836" cy="4219128"/>
+          </a:xfrm>
+          <a:prstGeom prst="rect">
+            <a:avLst/>
+          </a:prstGeom>
+        </p:spPr>
+      </p:pic>
+      <p:sp>
+        <p:nvSpPr>
+          <p:cNvPr id="15" name="CuadroTexto 14">
+            <a:extLst>
+              <a:ext uri="{FF2B5EF4-FFF2-40B4-BE49-F238E27FC236}">
+                <a16:creationId xmlns:a16="http://schemas.microsoft.com/office/drawing/2014/main" id="{33C4FF9D-126A-43C8-8615-C2375C01EB92}"/>
+              </a:ext>
+            </a:extLst>
+          </p:cNvPr>
+          <p:cNvSpPr txBox="1"/>
+          <p:nvPr/>
+        </p:nvSpPr>
+        <p:spPr>
+          <a:xfrm>
+            <a:off x="39835" y="6474822"/>
+            <a:ext cx="9034891" cy="338554"/>
+          </a:xfrm>
+          <a:prstGeom prst="rect">
+            <a:avLst/>
+          </a:prstGeom>
+          <a:solidFill>
+            <a:schemeClr val="accent2">
+              <a:lumMod val="20000"/>
+              <a:lumOff val="80000"/>
+            </a:schemeClr>
+          </a:solidFill>
+        </p:spPr>
+        <p:txBody>
+          <a:bodyPr wrap="square">
+            <a:spAutoFit/>
+          </a:bodyPr>
+          <a:lstStyle/>
+          <a:p>
+            <a:r>
+              <a:rPr lang="es-MX" sz="1600" dirty="0"/>
+              <a:t>No todo subproblema necesita ser una función: si es una sola línea, puede quedarse dentro de otra.</a:t>
+            </a:r>
+          </a:p>
+        </p:txBody>
+      </p:sp>
+    </p:spTree>
+    <p:extLst>
+      <p:ext uri="{BB962C8B-B14F-4D97-AF65-F5344CB8AC3E}">
+        <p14:creationId xmlns:p14="http://schemas.microsoft.com/office/powerpoint/2010/main" val="2624402780"/>
+      </p:ext>
+    </p:extLst>
+  </p:cSld>
+  <p:clrMapOvr>
+    <a:masterClrMapping/>
+  </p:clrMapOvr>
+</p:sld>
+</file>
+
+<file path=ppt/slides/slide32.xml><?xml version="1.0" encoding="utf-8"?>
+<p:sld xmlns:a="http://schemas.openxmlformats.org/drawingml/2006/main" xmlns:r="http://schemas.openxmlformats.org/officeDocument/2006/relationships" xmlns:p="http://schemas.openxmlformats.org/presentationml/2006/main">
+  <p:cSld>
+    <p:spTree>
+      <p:nvGrpSpPr>
+        <p:cNvPr id="1" name=""/>
+        <p:cNvGrpSpPr/>
+        <p:nvPr/>
+      </p:nvGrpSpPr>
+      <p:grpSpPr>
+        <a:xfrm>
+          <a:off x="0" y="0"/>
+          <a:ext cx="0" cy="0"/>
+          <a:chOff x="0" y="0"/>
+          <a:chExt cx="0" cy="0"/>
+        </a:xfrm>
+      </p:grpSpPr>
+      <p:sp>
+        <p:nvSpPr>
+          <p:cNvPr id="5" name="4 Título"/>
+          <p:cNvSpPr>
+            <a:spLocks noGrp="1"/>
+          </p:cNvSpPr>
+          <p:nvPr>
+            <p:ph type="title"/>
+          </p:nvPr>
+        </p:nvSpPr>
+        <p:spPr>
+          <a:xfrm>
+            <a:off x="308782" y="116632"/>
+            <a:ext cx="8835218" cy="720452"/>
+          </a:xfrm>
+        </p:spPr>
+        <p:txBody>
+          <a:bodyPr>
+            <a:noAutofit/>
+          </a:bodyPr>
+          <a:lstStyle/>
+          <a:p>
+            <a:r>
+              <a:rPr lang="en-US" sz="3600" dirty="0"/>
+              <a:t>¿Cómo se construye? Top-down y bottom-up</a:t>
+            </a:r>
+            <a:endParaRPr lang="es-MX" sz="3600" dirty="0"/>
+          </a:p>
+        </p:txBody>
+      </p:sp>
+      <p:sp>
+        <p:nvSpPr>
+          <p:cNvPr id="13" name="12 Rectángulo"/>
+          <p:cNvSpPr/>
+          <p:nvPr/>
+        </p:nvSpPr>
+        <p:spPr>
+          <a:xfrm>
+            <a:off x="179512" y="796642"/>
+            <a:ext cx="8835218" cy="5324535"/>
+          </a:xfrm>
+          <a:prstGeom prst="rect">
+            <a:avLst/>
+          </a:prstGeom>
+        </p:spPr>
+        <p:txBody>
+          <a:bodyPr wrap="square">
+            <a:spAutoFit/>
+          </a:bodyPr>
+          <a:lstStyle/>
+          <a:p>
+            <a:pPr marL="342900" indent="-342900" rtl="0">
+              <a:buFont typeface="Arial" panose="020B0604020202020204" pitchFamily="34" charset="0"/>
+              <a:buChar char="•"/>
+            </a:pPr>
+            <a:r>
+              <a:rPr lang="es-MX" sz="2000" dirty="0"/>
+              <a:t>La siguiente tabla ilustra los principales aspectos a tener en cuenta para abordar un problema complejo ya sea mediante </a:t>
+            </a:r>
+            <a:r>
+              <a:rPr lang="es-MX" sz="2000" b="1" dirty="0"/>
+              <a:t>top-</a:t>
+            </a:r>
+            <a:r>
+              <a:rPr lang="es-MX" sz="2000" b="1" dirty="0" err="1"/>
+              <a:t>down</a:t>
+            </a:r>
+            <a:r>
+              <a:rPr lang="es-MX" sz="2000" dirty="0"/>
+              <a:t> o mediante </a:t>
+            </a:r>
+            <a:r>
+              <a:rPr lang="es-MX" sz="2000" b="1" dirty="0" err="1"/>
+              <a:t>bottom</a:t>
+            </a:r>
+            <a:r>
+              <a:rPr lang="es-MX" sz="2000" b="1" dirty="0"/>
+              <a:t>-up</a:t>
+            </a:r>
+            <a:r>
+              <a:rPr lang="es-MX" sz="2000" dirty="0"/>
+              <a:t>.</a:t>
+            </a:r>
+          </a:p>
+          <a:p>
+            <a:pPr marL="342900" indent="-342900" rtl="0">
+              <a:buFont typeface="Arial" panose="020B0604020202020204" pitchFamily="34" charset="0"/>
+              <a:buChar char="•"/>
+            </a:pPr>
+            <a:endParaRPr lang="es-MX" sz="2000" dirty="0"/>
+          </a:p>
+          <a:p>
+            <a:pPr marL="342900" indent="-342900" rtl="0">
+              <a:buFont typeface="Arial" panose="020B0604020202020204" pitchFamily="34" charset="0"/>
+              <a:buChar char="•"/>
+            </a:pPr>
+            <a:endParaRPr lang="es-MX" sz="2000" dirty="0"/>
+          </a:p>
+          <a:p>
+            <a:pPr marL="342900" indent="-342900" rtl="0">
+              <a:buFont typeface="Arial" panose="020B0604020202020204" pitchFamily="34" charset="0"/>
+              <a:buChar char="•"/>
+            </a:pPr>
+            <a:endParaRPr lang="es-MX" sz="2000" dirty="0"/>
+          </a:p>
+          <a:p>
+            <a:pPr marL="342900" indent="-342900" rtl="0">
+              <a:buFont typeface="Arial" panose="020B0604020202020204" pitchFamily="34" charset="0"/>
+              <a:buChar char="•"/>
+            </a:pPr>
+            <a:endParaRPr lang="es-MX" sz="2000" dirty="0"/>
+          </a:p>
+          <a:p>
+            <a:pPr marL="342900" indent="-342900" rtl="0">
+              <a:buFont typeface="Arial" panose="020B0604020202020204" pitchFamily="34" charset="0"/>
+              <a:buChar char="•"/>
+            </a:pPr>
+            <a:endParaRPr lang="es-MX" sz="2000" dirty="0"/>
+          </a:p>
+          <a:p>
+            <a:pPr marL="342900" indent="-342900" rtl="0">
+              <a:buFont typeface="Arial" panose="020B0604020202020204" pitchFamily="34" charset="0"/>
+              <a:buChar char="•"/>
+            </a:pPr>
+            <a:endParaRPr lang="es-MX" sz="2000" dirty="0"/>
+          </a:p>
+          <a:p>
+            <a:pPr marL="342900" indent="-342900" rtl="0">
+              <a:buFont typeface="Arial" panose="020B0604020202020204" pitchFamily="34" charset="0"/>
+              <a:buChar char="•"/>
+            </a:pPr>
+            <a:endParaRPr lang="es-MX" sz="2000" dirty="0"/>
+          </a:p>
+          <a:p>
+            <a:pPr marL="342900" indent="-342900" rtl="0">
+              <a:buFont typeface="Arial" panose="020B0604020202020204" pitchFamily="34" charset="0"/>
+              <a:buChar char="•"/>
+            </a:pPr>
+            <a:endParaRPr lang="es-MX" sz="2000" dirty="0"/>
+          </a:p>
+          <a:p>
+            <a:pPr marL="342900" indent="-342900" rtl="0">
+              <a:buFont typeface="Arial" panose="020B0604020202020204" pitchFamily="34" charset="0"/>
+              <a:buChar char="•"/>
+            </a:pPr>
+            <a:endParaRPr lang="es-MX" sz="2000" dirty="0"/>
+          </a:p>
+          <a:p>
+            <a:pPr marL="342900" indent="-342900" rtl="0">
+              <a:buFont typeface="Arial" panose="020B0604020202020204" pitchFamily="34" charset="0"/>
+              <a:buChar char="•"/>
+            </a:pPr>
+            <a:endParaRPr lang="es-MX" sz="2000" dirty="0"/>
+          </a:p>
+          <a:p>
+            <a:pPr marL="342900" indent="-342900" rtl="0">
+              <a:buFont typeface="Arial" panose="020B0604020202020204" pitchFamily="34" charset="0"/>
+              <a:buChar char="•"/>
+            </a:pPr>
+            <a:endParaRPr lang="es-MX" sz="2000" dirty="0"/>
+          </a:p>
+          <a:p>
+            <a:pPr marL="342900" indent="-342900" rtl="0">
+              <a:buFont typeface="Arial" panose="020B0604020202020204" pitchFamily="34" charset="0"/>
+              <a:buChar char="•"/>
+            </a:pPr>
+            <a:endParaRPr lang="es-MX" sz="2000" dirty="0"/>
+          </a:p>
+          <a:p>
+            <a:pPr marL="342900" indent="-342900" rtl="0">
+              <a:buFont typeface="Arial" panose="020B0604020202020204" pitchFamily="34" charset="0"/>
+              <a:buChar char="•"/>
+            </a:pPr>
+            <a:r>
+              <a:rPr lang="es-MX" sz="2000" b="1" dirty="0"/>
+              <a:t>Lo que tienen en común</a:t>
+            </a:r>
+            <a:r>
+              <a:rPr lang="es-MX" sz="2000" dirty="0"/>
+              <a:t>: “los dos construyen una función a la vez, ayudan a aislar los errores y facilitan la depuración” (Liang, </a:t>
+            </a:r>
+            <a:r>
+              <a:rPr lang="es-CO" sz="2000" dirty="0"/>
+              <a:t>§6.13</a:t>
+            </a:r>
+            <a:r>
+              <a:rPr lang="es-MX" sz="2000" dirty="0"/>
+              <a:t>).</a:t>
+            </a:r>
+          </a:p>
+          <a:p>
+            <a:pPr marL="342900" indent="-342900" rtl="0">
+              <a:buFont typeface="Arial" panose="020B0604020202020204" pitchFamily="34" charset="0"/>
+              <a:buChar char="•"/>
+            </a:pPr>
+            <a:r>
+              <a:rPr lang="es-MX" sz="2000" dirty="0"/>
+              <a:t>Nunca se escribe todo para probarlo al final.</a:t>
+            </a:r>
+          </a:p>
+        </p:txBody>
+      </p:sp>
+      <p:graphicFrame>
+        <p:nvGraphicFramePr>
+          <p:cNvPr id="2" name="Tabla 1">
+            <a:extLst>
+              <a:ext uri="{FF2B5EF4-FFF2-40B4-BE49-F238E27FC236}">
+                <a16:creationId xmlns:a16="http://schemas.microsoft.com/office/drawing/2014/main" id="{8C462719-C3C9-4A70-A8F0-02BB0B1E60DB}"/>
+              </a:ext>
+            </a:extLst>
+          </p:cNvPr>
+          <p:cNvGraphicFramePr>
+            <a:graphicFrameLocks noGrp="1"/>
+          </p:cNvGraphicFramePr>
+          <p:nvPr>
+            <p:extLst>
+              <p:ext uri="{D42A27DB-BD31-4B8C-83A1-F6EECF244321}">
+                <p14:modId xmlns:p14="http://schemas.microsoft.com/office/powerpoint/2010/main" val="3363121036"/>
+              </p:ext>
+            </p:extLst>
+          </p:nvPr>
+        </p:nvGraphicFramePr>
+        <p:xfrm>
+          <a:off x="539552" y="1772816"/>
+          <a:ext cx="8208912" cy="3108960"/>
+        </p:xfrm>
+        <a:graphic>
+          <a:graphicData uri="http://schemas.openxmlformats.org/drawingml/2006/table">
+            <a:tbl>
+              <a:tblPr/>
+              <a:tblGrid>
+                <a:gridCol w="2736304">
+                  <a:extLst>
+                    <a:ext uri="{9D8B030D-6E8A-4147-A177-3AD203B41FA5}">
+                      <a16:colId xmlns:a16="http://schemas.microsoft.com/office/drawing/2014/main" val="3568930428"/>
+                    </a:ext>
+                  </a:extLst>
+                </a:gridCol>
+                <a:gridCol w="2736304">
+                  <a:extLst>
+                    <a:ext uri="{9D8B030D-6E8A-4147-A177-3AD203B41FA5}">
+                      <a16:colId xmlns:a16="http://schemas.microsoft.com/office/drawing/2014/main" val="4124702210"/>
+                    </a:ext>
+                  </a:extLst>
+                </a:gridCol>
+                <a:gridCol w="2736304">
+                  <a:extLst>
+                    <a:ext uri="{9D8B030D-6E8A-4147-A177-3AD203B41FA5}">
+                      <a16:colId xmlns:a16="http://schemas.microsoft.com/office/drawing/2014/main" val="3675448163"/>
+                    </a:ext>
+                  </a:extLst>
+                </a:gridCol>
+              </a:tblGrid>
+              <a:tr h="0">
+                <a:tc>
+                  <a:txBody>
+                    <a:bodyPr/>
+                    <a:lstStyle/>
+                    <a:p>
+                      <a:endParaRPr lang="es-CO"/>
+                    </a:p>
+                  </a:txBody>
+                  <a:tcPr anchor="ctr">
+                    <a:lnL>
+                      <a:noFill/>
+                    </a:lnL>
+                    <a:lnR w="12700" cap="flat" cmpd="sng" algn="ctr">
+                      <a:solidFill>
+                        <a:schemeClr val="tx1"/>
+                      </a:solidFill>
+                      <a:prstDash val="solid"/>
+                      <a:round/>
+                      <a:headEnd type="none" w="med" len="med"/>
+                      <a:tailEnd type="none" w="med" len="med"/>
+                    </a:lnR>
+                    <a:lnT>
+                      <a:noFill/>
+                    </a:lnT>
+                    <a:lnB w="12700" cap="flat" cmpd="sng" algn="ctr">
+                      <a:solidFill>
+                        <a:schemeClr val="tx1"/>
+                      </a:solidFill>
+                      <a:prstDash val="solid"/>
+                      <a:round/>
+                      <a:headEnd type="none" w="med" len="med"/>
+                      <a:tailEnd type="none" w="med" len="med"/>
+                    </a:lnB>
+                  </a:tcPr>
+                </a:tc>
+                <a:tc>
+                  <a:txBody>
+                    <a:bodyPr/>
+                    <a:lstStyle/>
+                    <a:p>
+                      <a:r>
+                        <a:rPr lang="es-CO" b="1" dirty="0"/>
+                        <a:t>Top-</a:t>
+                      </a:r>
+                      <a:r>
+                        <a:rPr lang="es-CO" b="1" dirty="0" err="1"/>
+                        <a:t>down</a:t>
+                      </a:r>
+                      <a:endParaRPr lang="es-CO" dirty="0"/>
+                    </a:p>
+                  </a:txBody>
+                  <a:tcPr anchor="ctr">
+                    <a:lnL w="12700" cap="flat" cmpd="sng" algn="ctr">
+                      <a:solidFill>
+                        <a:schemeClr val="tx1"/>
+                      </a:solidFill>
+                      <a:prstDash val="solid"/>
+                      <a:round/>
+                      <a:headEnd type="none" w="med" len="med"/>
+                      <a:tailEnd type="none" w="med" len="med"/>
+                    </a:lnL>
+                    <a:lnR w="12700" cap="flat" cmpd="sng" algn="ctr">
+                      <a:solidFill>
+                        <a:schemeClr val="tx1"/>
+                      </a:solidFill>
+                      <a:prstDash val="solid"/>
+                      <a:round/>
+                      <a:headEnd type="none" w="med" len="med"/>
+                      <a:tailEnd type="none" w="med" len="med"/>
+                    </a:lnR>
+                    <a:lnT w="12700" cap="flat" cmpd="sng" algn="ctr">
+                      <a:solidFill>
+                        <a:schemeClr val="tx1"/>
+                      </a:solidFill>
+                      <a:prstDash val="solid"/>
+                      <a:round/>
+                      <a:headEnd type="none" w="med" len="med"/>
+                      <a:tailEnd type="none" w="med" len="med"/>
+                    </a:lnT>
+                    <a:lnB w="12700" cap="flat" cmpd="sng" algn="ctr">
+                      <a:solidFill>
+                        <a:schemeClr val="tx1"/>
+                      </a:solidFill>
+                      <a:prstDash val="solid"/>
+                      <a:round/>
+                      <a:headEnd type="none" w="med" len="med"/>
+                      <a:tailEnd type="none" w="med" len="med"/>
+                    </a:lnB>
+                    <a:solidFill>
+                      <a:schemeClr val="bg1">
+                        <a:lumMod val="95000"/>
+                      </a:schemeClr>
+                    </a:solidFill>
+                  </a:tcPr>
+                </a:tc>
+                <a:tc>
+                  <a:txBody>
+                    <a:bodyPr/>
+                    <a:lstStyle/>
+                    <a:p>
+                      <a:r>
+                        <a:rPr lang="es-CO" b="1" dirty="0" err="1"/>
+                        <a:t>Bottom</a:t>
+                      </a:r>
+                      <a:r>
+                        <a:rPr lang="es-CO" b="1" dirty="0"/>
+                        <a:t>-up</a:t>
+                      </a:r>
+                      <a:endParaRPr lang="es-CO" dirty="0"/>
+                    </a:p>
+                  </a:txBody>
+                  <a:tcPr anchor="ctr">
+                    <a:lnL w="12700" cap="flat" cmpd="sng" algn="ctr">
+                      <a:solidFill>
+                        <a:schemeClr val="tx1"/>
+                      </a:solidFill>
+                      <a:prstDash val="solid"/>
+                      <a:round/>
+                      <a:headEnd type="none" w="med" len="med"/>
+                      <a:tailEnd type="none" w="med" len="med"/>
+                    </a:lnL>
+                    <a:lnR w="12700" cap="flat" cmpd="sng" algn="ctr">
+                      <a:solidFill>
+                        <a:schemeClr val="tx1"/>
+                      </a:solidFill>
+                      <a:prstDash val="solid"/>
+                      <a:round/>
+                      <a:headEnd type="none" w="med" len="med"/>
+                      <a:tailEnd type="none" w="med" len="med"/>
+                    </a:lnR>
+                    <a:lnT w="12700" cap="flat" cmpd="sng" algn="ctr">
+                      <a:solidFill>
+                        <a:schemeClr val="tx1"/>
+                      </a:solidFill>
+                      <a:prstDash val="solid"/>
+                      <a:round/>
+                      <a:headEnd type="none" w="med" len="med"/>
+                      <a:tailEnd type="none" w="med" len="med"/>
+                    </a:lnT>
+                    <a:lnB w="12700" cap="flat" cmpd="sng" algn="ctr">
+                      <a:solidFill>
+                        <a:schemeClr val="tx1"/>
+                      </a:solidFill>
+                      <a:prstDash val="solid"/>
+                      <a:round/>
+                      <a:headEnd type="none" w="med" len="med"/>
+                      <a:tailEnd type="none" w="med" len="med"/>
+                    </a:lnB>
+                    <a:solidFill>
+                      <a:schemeClr val="bg1">
+                        <a:lumMod val="95000"/>
+                      </a:schemeClr>
+                    </a:solidFill>
+                  </a:tcPr>
+                </a:tc>
+                <a:extLst>
+                  <a:ext uri="{0D108BD9-81ED-4DB2-BD59-A6C34878D82A}">
+                    <a16:rowId xmlns:a16="http://schemas.microsoft.com/office/drawing/2014/main" val="2616112531"/>
+                  </a:ext>
+                </a:extLst>
+              </a:tr>
+              <a:tr h="0">
+                <a:tc>
+                  <a:txBody>
+                    <a:bodyPr/>
+                    <a:lstStyle/>
+                    <a:p>
+                      <a:r>
+                        <a:rPr lang="es-CO" b="1" dirty="0"/>
+                        <a:t>Orden</a:t>
+                      </a:r>
+                      <a:endParaRPr lang="es-CO" dirty="0"/>
+                    </a:p>
+                  </a:txBody>
+                  <a:tcPr anchor="ctr">
+                    <a:lnL w="12700" cap="flat" cmpd="sng" algn="ctr">
+                      <a:solidFill>
+                        <a:schemeClr val="tx1"/>
+                      </a:solidFill>
+                      <a:prstDash val="solid"/>
+                      <a:round/>
+                      <a:headEnd type="none" w="med" len="med"/>
+                      <a:tailEnd type="none" w="med" len="med"/>
+                    </a:lnL>
+                    <a:lnR w="12700" cap="flat" cmpd="sng" algn="ctr">
+                      <a:solidFill>
+                        <a:schemeClr val="tx1"/>
+                      </a:solidFill>
+                      <a:prstDash val="solid"/>
+                      <a:round/>
+                      <a:headEnd type="none" w="med" len="med"/>
+                      <a:tailEnd type="none" w="med" len="med"/>
+                    </a:lnR>
+                    <a:lnT w="12700" cap="flat" cmpd="sng" algn="ctr">
+                      <a:solidFill>
+                        <a:schemeClr val="tx1"/>
+                      </a:solidFill>
+                      <a:prstDash val="solid"/>
+                      <a:round/>
+                      <a:headEnd type="none" w="med" len="med"/>
+                      <a:tailEnd type="none" w="med" len="med"/>
+                    </a:lnT>
+                    <a:lnB w="12700" cap="flat" cmpd="sng" algn="ctr">
+                      <a:solidFill>
+                        <a:schemeClr val="tx1"/>
+                      </a:solidFill>
+                      <a:prstDash val="solid"/>
+                      <a:round/>
+                      <a:headEnd type="none" w="med" len="med"/>
+                      <a:tailEnd type="none" w="med" len="med"/>
+                    </a:lnB>
+                    <a:solidFill>
+                      <a:schemeClr val="bg1">
+                        <a:lumMod val="95000"/>
+                      </a:schemeClr>
+                    </a:solidFill>
+                  </a:tcPr>
+                </a:tc>
+                <a:tc>
+                  <a:txBody>
+                    <a:bodyPr/>
+                    <a:lstStyle/>
+                    <a:p>
+                      <a:r>
+                        <a:rPr lang="es-MX" b="1" dirty="0"/>
+                        <a:t>De arriba hacia abajo</a:t>
+                      </a:r>
+                      <a:r>
+                        <a:rPr lang="es-MX" dirty="0"/>
+                        <a:t>: primero el programa principal</a:t>
+                      </a:r>
+                    </a:p>
+                  </a:txBody>
+                  <a:tcPr anchor="ctr">
+                    <a:lnL w="12700" cap="flat" cmpd="sng" algn="ctr">
+                      <a:solidFill>
+                        <a:schemeClr val="tx1"/>
+                      </a:solidFill>
+                      <a:prstDash val="solid"/>
+                      <a:round/>
+                      <a:headEnd type="none" w="med" len="med"/>
+                      <a:tailEnd type="none" w="med" len="med"/>
+                    </a:lnL>
+                    <a:lnR w="12700" cap="flat" cmpd="sng" algn="ctr">
+                      <a:solidFill>
+                        <a:schemeClr val="tx1"/>
+                      </a:solidFill>
+                      <a:prstDash val="solid"/>
+                      <a:round/>
+                      <a:headEnd type="none" w="med" len="med"/>
+                      <a:tailEnd type="none" w="med" len="med"/>
+                    </a:lnR>
+                    <a:lnT w="12700" cap="flat" cmpd="sng" algn="ctr">
+                      <a:solidFill>
+                        <a:schemeClr val="tx1"/>
+                      </a:solidFill>
+                      <a:prstDash val="solid"/>
+                      <a:round/>
+                      <a:headEnd type="none" w="med" len="med"/>
+                      <a:tailEnd type="none" w="med" len="med"/>
+                    </a:lnT>
+                    <a:lnB w="12700" cap="flat" cmpd="sng" algn="ctr">
+                      <a:solidFill>
+                        <a:schemeClr val="tx1"/>
+                      </a:solidFill>
+                      <a:prstDash val="solid"/>
+                      <a:round/>
+                      <a:headEnd type="none" w="med" len="med"/>
+                      <a:tailEnd type="none" w="med" len="med"/>
+                    </a:lnB>
+                  </a:tcPr>
+                </a:tc>
+                <a:tc>
+                  <a:txBody>
+                    <a:bodyPr/>
+                    <a:lstStyle/>
+                    <a:p>
+                      <a:r>
+                        <a:rPr lang="es-MX" b="1" dirty="0"/>
+                        <a:t>De abajo hacia arriba</a:t>
+                      </a:r>
+                      <a:r>
+                        <a:rPr lang="es-MX" dirty="0"/>
+                        <a:t>: primero las funciones más pequeñas</a:t>
+                      </a:r>
+                    </a:p>
+                  </a:txBody>
+                  <a:tcPr anchor="ctr">
+                    <a:lnL w="12700" cap="flat" cmpd="sng" algn="ctr">
+                      <a:solidFill>
+                        <a:schemeClr val="tx1"/>
+                      </a:solidFill>
+                      <a:prstDash val="solid"/>
+                      <a:round/>
+                      <a:headEnd type="none" w="med" len="med"/>
+                      <a:tailEnd type="none" w="med" len="med"/>
+                    </a:lnL>
+                    <a:lnR w="12700" cap="flat" cmpd="sng" algn="ctr">
+                      <a:solidFill>
+                        <a:schemeClr val="tx1"/>
+                      </a:solidFill>
+                      <a:prstDash val="solid"/>
+                      <a:round/>
+                      <a:headEnd type="none" w="med" len="med"/>
+                      <a:tailEnd type="none" w="med" len="med"/>
+                    </a:lnR>
+                    <a:lnT w="12700" cap="flat" cmpd="sng" algn="ctr">
+                      <a:solidFill>
+                        <a:schemeClr val="tx1"/>
+                      </a:solidFill>
+                      <a:prstDash val="solid"/>
+                      <a:round/>
+                      <a:headEnd type="none" w="med" len="med"/>
+                      <a:tailEnd type="none" w="med" len="med"/>
+                    </a:lnT>
+                    <a:lnB w="12700" cap="flat" cmpd="sng" algn="ctr">
+                      <a:solidFill>
+                        <a:schemeClr val="tx1"/>
+                      </a:solidFill>
+                      <a:prstDash val="solid"/>
+                      <a:round/>
+                      <a:headEnd type="none" w="med" len="med"/>
+                      <a:tailEnd type="none" w="med" len="med"/>
+                    </a:lnB>
+                  </a:tcPr>
+                </a:tc>
+                <a:extLst>
+                  <a:ext uri="{0D108BD9-81ED-4DB2-BD59-A6C34878D82A}">
+                    <a16:rowId xmlns:a16="http://schemas.microsoft.com/office/drawing/2014/main" val="1502789637"/>
+                  </a:ext>
+                </a:extLst>
+              </a:tr>
+              <a:tr h="0">
+                <a:tc>
+                  <a:txBody>
+                    <a:bodyPr/>
+                    <a:lstStyle/>
+                    <a:p>
+                      <a:r>
+                        <a:rPr lang="es-MX" b="1" dirty="0"/>
+                        <a:t>Lo que falta se reemplaza por…</a:t>
+                      </a:r>
+                      <a:endParaRPr lang="es-MX" dirty="0"/>
+                    </a:p>
+                  </a:txBody>
+                  <a:tcPr anchor="ctr">
+                    <a:lnL w="12700" cap="flat" cmpd="sng" algn="ctr">
+                      <a:solidFill>
+                        <a:schemeClr val="tx1"/>
+                      </a:solidFill>
+                      <a:prstDash val="solid"/>
+                      <a:round/>
+                      <a:headEnd type="none" w="med" len="med"/>
+                      <a:tailEnd type="none" w="med" len="med"/>
+                    </a:lnL>
+                    <a:lnR w="12700" cap="flat" cmpd="sng" algn="ctr">
+                      <a:solidFill>
+                        <a:schemeClr val="tx1"/>
+                      </a:solidFill>
+                      <a:prstDash val="solid"/>
+                      <a:round/>
+                      <a:headEnd type="none" w="med" len="med"/>
+                      <a:tailEnd type="none" w="med" len="med"/>
+                    </a:lnR>
+                    <a:lnT w="12700" cap="flat" cmpd="sng" algn="ctr">
+                      <a:solidFill>
+                        <a:schemeClr val="tx1"/>
+                      </a:solidFill>
+                      <a:prstDash val="solid"/>
+                      <a:round/>
+                      <a:headEnd type="none" w="med" len="med"/>
+                      <a:tailEnd type="none" w="med" len="med"/>
+                    </a:lnT>
+                    <a:lnB w="12700" cap="flat" cmpd="sng" algn="ctr">
+                      <a:solidFill>
+                        <a:schemeClr val="tx1"/>
+                      </a:solidFill>
+                      <a:prstDash val="solid"/>
+                      <a:round/>
+                      <a:headEnd type="none" w="med" len="med"/>
+                      <a:tailEnd type="none" w="med" len="med"/>
+                    </a:lnB>
+                    <a:solidFill>
+                      <a:schemeClr val="bg1">
+                        <a:lumMod val="95000"/>
+                      </a:schemeClr>
+                    </a:solidFill>
+                  </a:tcPr>
+                </a:tc>
+                <a:tc>
+                  <a:txBody>
+                    <a:bodyPr/>
+                    <a:lstStyle/>
+                    <a:p>
+                      <a:r>
+                        <a:rPr lang="es-MX" b="1"/>
+                        <a:t>Stubs:</a:t>
+                      </a:r>
+                      <a:r>
+                        <a:rPr lang="es-MX"/>
+                        <a:t> versiones provisionales e incompletas de una función</a:t>
+                      </a:r>
+                    </a:p>
+                  </a:txBody>
+                  <a:tcPr anchor="ctr">
+                    <a:lnL w="12700" cap="flat" cmpd="sng" algn="ctr">
+                      <a:solidFill>
+                        <a:schemeClr val="tx1"/>
+                      </a:solidFill>
+                      <a:prstDash val="solid"/>
+                      <a:round/>
+                      <a:headEnd type="none" w="med" len="med"/>
+                      <a:tailEnd type="none" w="med" len="med"/>
+                    </a:lnL>
+                    <a:lnR w="12700" cap="flat" cmpd="sng" algn="ctr">
+                      <a:solidFill>
+                        <a:schemeClr val="tx1"/>
+                      </a:solidFill>
+                      <a:prstDash val="solid"/>
+                      <a:round/>
+                      <a:headEnd type="none" w="med" len="med"/>
+                      <a:tailEnd type="none" w="med" len="med"/>
+                    </a:lnR>
+                    <a:lnT w="12700" cap="flat" cmpd="sng" algn="ctr">
+                      <a:solidFill>
+                        <a:schemeClr val="tx1"/>
+                      </a:solidFill>
+                      <a:prstDash val="solid"/>
+                      <a:round/>
+                      <a:headEnd type="none" w="med" len="med"/>
+                      <a:tailEnd type="none" w="med" len="med"/>
+                    </a:lnT>
+                    <a:lnB w="12700" cap="flat" cmpd="sng" algn="ctr">
+                      <a:solidFill>
+                        <a:schemeClr val="tx1"/>
+                      </a:solidFill>
+                      <a:prstDash val="solid"/>
+                      <a:round/>
+                      <a:headEnd type="none" w="med" len="med"/>
+                      <a:tailEnd type="none" w="med" len="med"/>
+                    </a:lnB>
+                  </a:tcPr>
+                </a:tc>
+                <a:tc>
+                  <a:txBody>
+                    <a:bodyPr/>
+                    <a:lstStyle/>
+                    <a:p>
+                      <a:r>
+                        <a:rPr lang="es-MX" b="1" dirty="0"/>
+                        <a:t>Drivers:</a:t>
+                      </a:r>
+                      <a:r>
+                        <a:rPr lang="es-MX" dirty="0"/>
+                        <a:t> pequeños programas de prueba, como nuestros assert</a:t>
+                      </a:r>
+                    </a:p>
+                  </a:txBody>
+                  <a:tcPr anchor="ctr">
+                    <a:lnL w="12700" cap="flat" cmpd="sng" algn="ctr">
+                      <a:solidFill>
+                        <a:schemeClr val="tx1"/>
+                      </a:solidFill>
+                      <a:prstDash val="solid"/>
+                      <a:round/>
+                      <a:headEnd type="none" w="med" len="med"/>
+                      <a:tailEnd type="none" w="med" len="med"/>
+                    </a:lnL>
+                    <a:lnR w="12700" cap="flat" cmpd="sng" algn="ctr">
+                      <a:solidFill>
+                        <a:schemeClr val="tx1"/>
+                      </a:solidFill>
+                      <a:prstDash val="solid"/>
+                      <a:round/>
+                      <a:headEnd type="none" w="med" len="med"/>
+                      <a:tailEnd type="none" w="med" len="med"/>
+                    </a:lnR>
+                    <a:lnT w="12700" cap="flat" cmpd="sng" algn="ctr">
+                      <a:solidFill>
+                        <a:schemeClr val="tx1"/>
+                      </a:solidFill>
+                      <a:prstDash val="solid"/>
+                      <a:round/>
+                      <a:headEnd type="none" w="med" len="med"/>
+                      <a:tailEnd type="none" w="med" len="med"/>
+                    </a:lnT>
+                    <a:lnB w="12700" cap="flat" cmpd="sng" algn="ctr">
+                      <a:solidFill>
+                        <a:schemeClr val="tx1"/>
+                      </a:solidFill>
+                      <a:prstDash val="solid"/>
+                      <a:round/>
+                      <a:headEnd type="none" w="med" len="med"/>
+                      <a:tailEnd type="none" w="med" len="med"/>
+                    </a:lnB>
+                  </a:tcPr>
+                </a:tc>
+                <a:extLst>
+                  <a:ext uri="{0D108BD9-81ED-4DB2-BD59-A6C34878D82A}">
+                    <a16:rowId xmlns:a16="http://schemas.microsoft.com/office/drawing/2014/main" val="2090159382"/>
+                  </a:ext>
+                </a:extLst>
+              </a:tr>
+              <a:tr h="0">
+                <a:tc>
+                  <a:txBody>
+                    <a:bodyPr/>
+                    <a:lstStyle/>
+                    <a:p>
+                      <a:r>
+                        <a:rPr lang="es-CO" b="1" dirty="0"/>
+                        <a:t>Ventaja</a:t>
+                      </a:r>
+                      <a:endParaRPr lang="es-CO" dirty="0"/>
+                    </a:p>
+                  </a:txBody>
+                  <a:tcPr anchor="ctr">
+                    <a:lnL w="12700" cap="flat" cmpd="sng" algn="ctr">
+                      <a:solidFill>
+                        <a:schemeClr val="tx1"/>
+                      </a:solidFill>
+                      <a:prstDash val="solid"/>
+                      <a:round/>
+                      <a:headEnd type="none" w="med" len="med"/>
+                      <a:tailEnd type="none" w="med" len="med"/>
+                    </a:lnL>
+                    <a:lnR w="12700" cap="flat" cmpd="sng" algn="ctr">
+                      <a:solidFill>
+                        <a:schemeClr val="tx1"/>
+                      </a:solidFill>
+                      <a:prstDash val="solid"/>
+                      <a:round/>
+                      <a:headEnd type="none" w="med" len="med"/>
+                      <a:tailEnd type="none" w="med" len="med"/>
+                    </a:lnR>
+                    <a:lnT w="12700" cap="flat" cmpd="sng" algn="ctr">
+                      <a:solidFill>
+                        <a:schemeClr val="tx1"/>
+                      </a:solidFill>
+                      <a:prstDash val="solid"/>
+                      <a:round/>
+                      <a:headEnd type="none" w="med" len="med"/>
+                      <a:tailEnd type="none" w="med" len="med"/>
+                    </a:lnT>
+                    <a:lnB w="12700" cap="flat" cmpd="sng" algn="ctr">
+                      <a:solidFill>
+                        <a:schemeClr val="tx1"/>
+                      </a:solidFill>
+                      <a:prstDash val="solid"/>
+                      <a:round/>
+                      <a:headEnd type="none" w="med" len="med"/>
+                      <a:tailEnd type="none" w="med" len="med"/>
+                    </a:lnB>
+                    <a:solidFill>
+                      <a:schemeClr val="bg1">
+                        <a:lumMod val="95000"/>
+                      </a:schemeClr>
+                    </a:solidFill>
+                  </a:tcPr>
+                </a:tc>
+                <a:tc>
+                  <a:txBody>
+                    <a:bodyPr/>
+                    <a:lstStyle/>
+                    <a:p>
+                      <a:r>
+                        <a:rPr lang="es-MX" dirty="0"/>
+                        <a:t>El programa corre desde el primer momento</a:t>
+                      </a:r>
+                    </a:p>
+                  </a:txBody>
+                  <a:tcPr anchor="ctr">
+                    <a:lnL w="12700" cap="flat" cmpd="sng" algn="ctr">
+                      <a:solidFill>
+                        <a:schemeClr val="tx1"/>
+                      </a:solidFill>
+                      <a:prstDash val="solid"/>
+                      <a:round/>
+                      <a:headEnd type="none" w="med" len="med"/>
+                      <a:tailEnd type="none" w="med" len="med"/>
+                    </a:lnL>
+                    <a:lnR w="12700" cap="flat" cmpd="sng" algn="ctr">
+                      <a:solidFill>
+                        <a:schemeClr val="tx1"/>
+                      </a:solidFill>
+                      <a:prstDash val="solid"/>
+                      <a:round/>
+                      <a:headEnd type="none" w="med" len="med"/>
+                      <a:tailEnd type="none" w="med" len="med"/>
+                    </a:lnR>
+                    <a:lnT w="12700" cap="flat" cmpd="sng" algn="ctr">
+                      <a:solidFill>
+                        <a:schemeClr val="tx1"/>
+                      </a:solidFill>
+                      <a:prstDash val="solid"/>
+                      <a:round/>
+                      <a:headEnd type="none" w="med" len="med"/>
+                      <a:tailEnd type="none" w="med" len="med"/>
+                    </a:lnT>
+                    <a:lnB w="12700" cap="flat" cmpd="sng" algn="ctr">
+                      <a:solidFill>
+                        <a:schemeClr val="tx1"/>
+                      </a:solidFill>
+                      <a:prstDash val="solid"/>
+                      <a:round/>
+                      <a:headEnd type="none" w="med" len="med"/>
+                      <a:tailEnd type="none" w="med" len="med"/>
+                    </a:lnB>
+                  </a:tcPr>
+                </a:tc>
+                <a:tc>
+                  <a:txBody>
+                    <a:bodyPr/>
+                    <a:lstStyle/>
+                    <a:p>
+                      <a:r>
+                        <a:rPr lang="es-MX" dirty="0"/>
+                        <a:t>Cada pieza llega probada a la integración</a:t>
+                      </a:r>
+                    </a:p>
+                  </a:txBody>
+                  <a:tcPr anchor="ctr">
+                    <a:lnL w="12700" cap="flat" cmpd="sng" algn="ctr">
+                      <a:solidFill>
+                        <a:schemeClr val="tx1"/>
+                      </a:solidFill>
+                      <a:prstDash val="solid"/>
+                      <a:round/>
+                      <a:headEnd type="none" w="med" len="med"/>
+                      <a:tailEnd type="none" w="med" len="med"/>
+                    </a:lnL>
+                    <a:lnR w="12700" cap="flat" cmpd="sng" algn="ctr">
+                      <a:solidFill>
+                        <a:schemeClr val="tx1"/>
+                      </a:solidFill>
+                      <a:prstDash val="solid"/>
+                      <a:round/>
+                      <a:headEnd type="none" w="med" len="med"/>
+                      <a:tailEnd type="none" w="med" len="med"/>
+                    </a:lnR>
+                    <a:lnT w="12700" cap="flat" cmpd="sng" algn="ctr">
+                      <a:solidFill>
+                        <a:schemeClr val="tx1"/>
+                      </a:solidFill>
+                      <a:prstDash val="solid"/>
+                      <a:round/>
+                      <a:headEnd type="none" w="med" len="med"/>
+                      <a:tailEnd type="none" w="med" len="med"/>
+                    </a:lnT>
+                    <a:lnB w="12700" cap="flat" cmpd="sng" algn="ctr">
+                      <a:solidFill>
+                        <a:schemeClr val="tx1"/>
+                      </a:solidFill>
+                      <a:prstDash val="solid"/>
+                      <a:round/>
+                      <a:headEnd type="none" w="med" len="med"/>
+                      <a:tailEnd type="none" w="med" len="med"/>
+                    </a:lnB>
+                  </a:tcPr>
+                </a:tc>
+                <a:extLst>
+                  <a:ext uri="{0D108BD9-81ED-4DB2-BD59-A6C34878D82A}">
+                    <a16:rowId xmlns:a16="http://schemas.microsoft.com/office/drawing/2014/main" val="998547987"/>
+                  </a:ext>
+                </a:extLst>
+              </a:tr>
+            </a:tbl>
+          </a:graphicData>
+        </a:graphic>
+      </p:graphicFrame>
+    </p:spTree>
+    <p:extLst>
+      <p:ext uri="{BB962C8B-B14F-4D97-AF65-F5344CB8AC3E}">
+        <p14:creationId xmlns:p14="http://schemas.microsoft.com/office/powerpoint/2010/main" val="2476027586"/>
+      </p:ext>
+    </p:extLst>
+  </p:cSld>
+  <p:clrMapOvr>
+    <a:masterClrMapping/>
+  </p:clrMapOvr>
+</p:sld>
+</file>
+
+<file path=ppt/slides/slide33.xml><?xml version="1.0" encoding="utf-8"?>
+<p:sld xmlns:a="http://schemas.openxmlformats.org/drawingml/2006/main" xmlns:r="http://schemas.openxmlformats.org/officeDocument/2006/relationships" xmlns:p="http://schemas.openxmlformats.org/presentationml/2006/main">
+  <p:cSld>
+    <p:spTree>
+      <p:nvGrpSpPr>
+        <p:cNvPr id="1" name=""/>
+        <p:cNvGrpSpPr/>
+        <p:nvPr/>
+      </p:nvGrpSpPr>
+      <p:grpSpPr>
+        <a:xfrm>
+          <a:off x="0" y="0"/>
+          <a:ext cx="0" cy="0"/>
+          <a:chOff x="0" y="0"/>
+          <a:chExt cx="0" cy="0"/>
+        </a:xfrm>
+      </p:grpSpPr>
+      <p:sp>
+        <p:nvSpPr>
+          <p:cNvPr id="5" name="4 Título"/>
+          <p:cNvSpPr>
+            <a:spLocks noGrp="1"/>
+          </p:cNvSpPr>
+          <p:nvPr>
+            <p:ph type="title"/>
+          </p:nvPr>
+        </p:nvSpPr>
+        <p:spPr>
+          <a:xfrm>
+            <a:off x="308782" y="116632"/>
+            <a:ext cx="8835218" cy="720452"/>
+          </a:xfrm>
+        </p:spPr>
+        <p:txBody>
+          <a:bodyPr>
+            <a:noAutofit/>
+          </a:bodyPr>
+          <a:lstStyle/>
+          <a:p>
+            <a:r>
+              <a:rPr lang="en-US" sz="3600" dirty="0"/>
+              <a:t>Top-down: Del planteamiento al </a:t>
+            </a:r>
+            <a:r>
+              <a:rPr lang="en-US" sz="3600" dirty="0" err="1"/>
+              <a:t>código</a:t>
+            </a:r>
+            <a:endParaRPr lang="es-MX" sz="3600" dirty="0"/>
+          </a:p>
+        </p:txBody>
+      </p:sp>
+      <p:sp>
+        <p:nvSpPr>
+          <p:cNvPr id="13" name="12 Rectángulo"/>
+          <p:cNvSpPr/>
+          <p:nvPr/>
+        </p:nvSpPr>
+        <p:spPr>
+          <a:xfrm>
+            <a:off x="179512" y="796642"/>
+            <a:ext cx="8835218" cy="5324535"/>
+          </a:xfrm>
+          <a:prstGeom prst="rect">
+            <a:avLst/>
+          </a:prstGeom>
+        </p:spPr>
+        <p:txBody>
+          <a:bodyPr wrap="square">
+            <a:spAutoFit/>
+          </a:bodyPr>
+          <a:lstStyle/>
+          <a:p>
+            <a:pPr marL="342900" indent="-342900" rtl="0">
+              <a:buFont typeface="Arial" panose="020B0604020202020204" pitchFamily="34" charset="0"/>
+              <a:buChar char="•"/>
+            </a:pPr>
+            <a:r>
+              <a:rPr lang="es-MX" sz="2000" dirty="0"/>
+              <a:t>La siguiente tabla ilustra los principales aspectos a tener en cuenta para abordar un problema complejo ya sea mediante </a:t>
+            </a:r>
+            <a:r>
+              <a:rPr lang="es-MX" sz="2000" b="1" dirty="0"/>
+              <a:t>top-</a:t>
+            </a:r>
+            <a:r>
+              <a:rPr lang="es-MX" sz="2000" b="1" dirty="0" err="1"/>
+              <a:t>down</a:t>
+            </a:r>
+            <a:r>
+              <a:rPr lang="es-MX" sz="2000" dirty="0"/>
+              <a:t> o mediante </a:t>
+            </a:r>
+            <a:r>
+              <a:rPr lang="es-MX" sz="2000" b="1" dirty="0" err="1"/>
+              <a:t>bottom</a:t>
+            </a:r>
+            <a:r>
+              <a:rPr lang="es-MX" sz="2000" b="1" dirty="0"/>
+              <a:t>-up</a:t>
+            </a:r>
+            <a:r>
+              <a:rPr lang="es-MX" sz="2000" dirty="0"/>
+              <a:t>.</a:t>
+            </a:r>
+          </a:p>
+          <a:p>
+            <a:pPr marL="342900" indent="-342900" rtl="0">
+              <a:buFont typeface="Arial" panose="020B0604020202020204" pitchFamily="34" charset="0"/>
+              <a:buChar char="•"/>
+            </a:pPr>
+            <a:endParaRPr lang="es-MX" sz="2000" dirty="0"/>
+          </a:p>
+          <a:p>
+            <a:pPr marL="342900" indent="-342900" rtl="0">
+              <a:buFont typeface="Arial" panose="020B0604020202020204" pitchFamily="34" charset="0"/>
+              <a:buChar char="•"/>
+            </a:pPr>
+            <a:endParaRPr lang="es-MX" sz="2000" dirty="0"/>
+          </a:p>
+          <a:p>
+            <a:pPr marL="342900" indent="-342900" rtl="0">
+              <a:buFont typeface="Arial" panose="020B0604020202020204" pitchFamily="34" charset="0"/>
+              <a:buChar char="•"/>
+            </a:pPr>
+            <a:endParaRPr lang="es-MX" sz="2000" dirty="0"/>
+          </a:p>
+          <a:p>
+            <a:pPr marL="342900" indent="-342900" rtl="0">
+              <a:buFont typeface="Arial" panose="020B0604020202020204" pitchFamily="34" charset="0"/>
+              <a:buChar char="•"/>
+            </a:pPr>
+            <a:endParaRPr lang="es-MX" sz="2000" dirty="0"/>
+          </a:p>
+          <a:p>
+            <a:pPr marL="342900" indent="-342900" rtl="0">
+              <a:buFont typeface="Arial" panose="020B0604020202020204" pitchFamily="34" charset="0"/>
+              <a:buChar char="•"/>
+            </a:pPr>
+            <a:endParaRPr lang="es-MX" sz="2000" dirty="0"/>
+          </a:p>
+          <a:p>
+            <a:pPr marL="342900" indent="-342900" rtl="0">
+              <a:buFont typeface="Arial" panose="020B0604020202020204" pitchFamily="34" charset="0"/>
+              <a:buChar char="•"/>
+            </a:pPr>
+            <a:endParaRPr lang="es-MX" sz="2000" dirty="0"/>
+          </a:p>
+          <a:p>
+            <a:pPr marL="342900" indent="-342900" rtl="0">
+              <a:buFont typeface="Arial" panose="020B0604020202020204" pitchFamily="34" charset="0"/>
+              <a:buChar char="•"/>
+            </a:pPr>
+            <a:endParaRPr lang="es-MX" sz="2000" dirty="0"/>
+          </a:p>
+          <a:p>
+            <a:pPr marL="342900" indent="-342900" rtl="0">
+              <a:buFont typeface="Arial" panose="020B0604020202020204" pitchFamily="34" charset="0"/>
+              <a:buChar char="•"/>
+            </a:pPr>
+            <a:endParaRPr lang="es-MX" sz="2000" dirty="0"/>
+          </a:p>
+          <a:p>
+            <a:pPr marL="342900" indent="-342900" rtl="0">
+              <a:buFont typeface="Arial" panose="020B0604020202020204" pitchFamily="34" charset="0"/>
+              <a:buChar char="•"/>
+            </a:pPr>
+            <a:endParaRPr lang="es-MX" sz="2000" dirty="0"/>
+          </a:p>
+          <a:p>
+            <a:pPr marL="342900" indent="-342900" rtl="0">
+              <a:buFont typeface="Arial" panose="020B0604020202020204" pitchFamily="34" charset="0"/>
+              <a:buChar char="•"/>
+            </a:pPr>
+            <a:endParaRPr lang="es-MX" sz="2000" dirty="0"/>
+          </a:p>
+          <a:p>
+            <a:pPr marL="342900" indent="-342900" rtl="0">
+              <a:buFont typeface="Arial" panose="020B0604020202020204" pitchFamily="34" charset="0"/>
+              <a:buChar char="•"/>
+            </a:pPr>
+            <a:endParaRPr lang="es-MX" sz="2000" dirty="0"/>
+          </a:p>
+          <a:p>
+            <a:pPr marL="342900" indent="-342900" rtl="0">
+              <a:buFont typeface="Arial" panose="020B0604020202020204" pitchFamily="34" charset="0"/>
+              <a:buChar char="•"/>
+            </a:pPr>
+            <a:endParaRPr lang="es-MX" sz="2000" dirty="0"/>
+          </a:p>
+          <a:p>
+            <a:pPr marL="342900" indent="-342900" rtl="0">
+              <a:buFont typeface="Arial" panose="020B0604020202020204" pitchFamily="34" charset="0"/>
+              <a:buChar char="•"/>
+            </a:pPr>
+            <a:r>
+              <a:rPr lang="es-MX" sz="2000" b="1" dirty="0"/>
+              <a:t>Lo que tienen en común</a:t>
+            </a:r>
+            <a:r>
+              <a:rPr lang="es-MX" sz="2000" dirty="0"/>
+              <a:t>: “los dos construyen una función a la vez, ayudan a aislar los errores y facilitan la depuración” (Liang, </a:t>
+            </a:r>
+            <a:r>
+              <a:rPr lang="es-CO" sz="2000" dirty="0"/>
+              <a:t>§6.13</a:t>
+            </a:r>
+            <a:r>
+              <a:rPr lang="es-MX" sz="2000" dirty="0"/>
+              <a:t>).</a:t>
+            </a:r>
+          </a:p>
+          <a:p>
+            <a:pPr marL="342900" indent="-342900" rtl="0">
+              <a:buFont typeface="Arial" panose="020B0604020202020204" pitchFamily="34" charset="0"/>
+              <a:buChar char="•"/>
+            </a:pPr>
+            <a:r>
+              <a:rPr lang="es-MX" sz="2000" dirty="0"/>
+              <a:t>Nunca se escribe todo para probarlo al final.</a:t>
+            </a:r>
+          </a:p>
+        </p:txBody>
+      </p:sp>
+    </p:spTree>
+    <p:extLst>
+      <p:ext uri="{BB962C8B-B14F-4D97-AF65-F5344CB8AC3E}">
+        <p14:creationId xmlns:p14="http://schemas.microsoft.com/office/powerpoint/2010/main" val="3763786917"/>
+      </p:ext>
+    </p:extLst>
+  </p:cSld>
+  <p:clrMapOvr>
+    <a:masterClrMapping/>
+  </p:clrMapOvr>
+</p:sld>
+</file>
+
+<file path=ppt/slides/slide34.xml><?xml version="1.0" encoding="utf-8"?>
+<p:sld xmlns:a="http://schemas.openxmlformats.org/drawingml/2006/main" xmlns:r="http://schemas.openxmlformats.org/officeDocument/2006/relationships" xmlns:p="http://schemas.openxmlformats.org/presentationml/2006/main">
+  <p:cSld>
+    <p:spTree>
+      <p:nvGrpSpPr>
+        <p:cNvPr id="1" name=""/>
+        <p:cNvGrpSpPr/>
+        <p:nvPr/>
+      </p:nvGrpSpPr>
+      <p:grpSpPr>
+        <a:xfrm>
+          <a:off x="0" y="0"/>
+          <a:ext cx="0" cy="0"/>
+          <a:chOff x="0" y="0"/>
+          <a:chExt cx="0" cy="0"/>
+        </a:xfrm>
+      </p:grpSpPr>
+      <p:sp>
+        <p:nvSpPr>
+          <p:cNvPr id="5" name="Title 4"/>
+          <p:cNvSpPr>
+            <a:spLocks noGrp="1"/>
+          </p:cNvSpPr>
+          <p:nvPr>
+            <p:ph type="title"/>
+          </p:nvPr>
+        </p:nvSpPr>
+        <p:spPr>
+          <a:xfrm>
+            <a:off x="107504" y="23817"/>
+            <a:ext cx="7886700" cy="812895"/>
+          </a:xfrm>
+        </p:spPr>
+        <p:txBody>
+          <a:bodyPr>
+            <a:normAutofit/>
+          </a:bodyPr>
+          <a:lstStyle/>
+          <a:p>
+            <a:r>
+              <a:rPr lang="en-US" sz="4000" dirty="0"/>
+              <a:t>Referencias</a:t>
+            </a:r>
+          </a:p>
+        </p:txBody>
+      </p:sp>
+      <p:sp>
+        <p:nvSpPr>
+          <p:cNvPr id="2" name="Content Placeholder 1"/>
+          <p:cNvSpPr>
+            <a:spLocks noGrp="1"/>
+          </p:cNvSpPr>
+          <p:nvPr>
+            <p:ph idx="1"/>
+          </p:nvPr>
+        </p:nvSpPr>
+        <p:spPr>
+          <a:xfrm>
+            <a:off x="179512" y="692696"/>
+            <a:ext cx="8712968" cy="6048672"/>
+          </a:xfrm>
+        </p:spPr>
+        <p:txBody>
+          <a:bodyPr>
+            <a:noAutofit/>
+          </a:bodyPr>
+          <a:lstStyle/>
+          <a:p>
+            <a:pPr rtl="0">
+              <a:buFont typeface="Arial" panose="020B0604020202020204" pitchFamily="34" charset="0"/>
+              <a:buChar char="•"/>
+            </a:pPr>
+            <a:r>
+              <a:rPr lang="es-MX" sz="2000" dirty="0"/>
+              <a:t>Aprender a Programar: Abstracción en programación. Concepto. Diseño top-</a:t>
+            </a:r>
+            <a:r>
+              <a:rPr lang="es-MX" sz="2000" dirty="0" err="1"/>
+              <a:t>down</a:t>
+            </a:r>
+            <a:r>
+              <a:rPr lang="es-MX" sz="2000" dirty="0"/>
+              <a:t> de algoritmos y programas. Ejemplos (CU00225A) </a:t>
+            </a:r>
+            <a:r>
+              <a:rPr lang="es-MX" sz="2000" dirty="0">
+                <a:hlinkClick r:id="rId2"/>
+              </a:rPr>
+              <a:t>https://www.aprenderaprogramar.com/index.php?option=com_content&amp;view=category&amp;id=36&amp;Itemid=60</a:t>
+            </a:r>
+            <a:r>
+              <a:rPr lang="es-MX" sz="2000" dirty="0"/>
+              <a:t>  </a:t>
+            </a:r>
+          </a:p>
+          <a:p>
+            <a:pPr rtl="0">
+              <a:buFont typeface="Arial" panose="020B0604020202020204" pitchFamily="34" charset="0"/>
+              <a:buChar char="•"/>
+            </a:pPr>
+            <a:r>
+              <a:rPr lang="es-MX" sz="2000" dirty="0"/>
+              <a:t>Stanford CS106A, </a:t>
+            </a:r>
+            <a:r>
+              <a:rPr lang="es-MX" sz="2000" i="1" dirty="0"/>
+              <a:t>Karel Reader</a:t>
+            </a:r>
+            <a:r>
+              <a:rPr lang="es-MX" sz="2000" dirty="0"/>
+              <a:t>, cap. 8: </a:t>
+            </a:r>
+            <a:r>
+              <a:rPr lang="es-MX" sz="2000" i="1" dirty="0" err="1"/>
+              <a:t>Stepwise</a:t>
+            </a:r>
+            <a:r>
+              <a:rPr lang="es-MX" sz="2000" i="1" dirty="0"/>
+              <a:t> </a:t>
+            </a:r>
+            <a:r>
+              <a:rPr lang="es-MX" sz="2000" i="1" dirty="0" err="1"/>
+              <a:t>Refinement</a:t>
+            </a:r>
+            <a:br>
+              <a:rPr lang="es-MX" sz="2000" dirty="0"/>
+            </a:br>
+            <a:r>
+              <a:rPr lang="es-MX" sz="2000" dirty="0">
+                <a:hlinkClick r:id="rId3"/>
+              </a:rPr>
+              <a:t>https://compedu.stanford.edu/karel-reader/docs/python/en/chapter8.html</a:t>
+            </a:r>
+            <a:endParaRPr lang="es-MX" sz="2000" dirty="0"/>
+          </a:p>
+          <a:p>
+            <a:pPr rtl="0">
+              <a:buFont typeface="Arial" panose="020B0604020202020204" pitchFamily="34" charset="0"/>
+              <a:buChar char="•"/>
+            </a:pPr>
+            <a:r>
+              <a:rPr lang="es-MX" sz="2000" dirty="0"/>
+              <a:t>Stanford CS106A, lección 3: </a:t>
+            </a:r>
+            <a:r>
+              <a:rPr lang="es-MX" sz="2000" i="1" dirty="0" err="1"/>
+              <a:t>Decomposition</a:t>
+            </a:r>
+            <a:br>
+              <a:rPr lang="es-MX" sz="2000" dirty="0"/>
+            </a:br>
+            <a:r>
+              <a:rPr lang="es-MX" sz="2000" dirty="0">
+                <a:hlinkClick r:id="rId4"/>
+              </a:rPr>
+              <a:t>https://web.stanford.edu/class/archive/cs/cs106a/cs106a.1226/lectures/03-decomposition/3-Decomposition.pdf</a:t>
+            </a:r>
+            <a:endParaRPr lang="es-MX" sz="2000" dirty="0"/>
+          </a:p>
+          <a:p>
+            <a:pPr rtl="0">
+              <a:buFont typeface="Arial" panose="020B0604020202020204" pitchFamily="34" charset="0"/>
+              <a:buChar char="•"/>
+            </a:pPr>
+            <a:r>
+              <a:rPr lang="es-MX" sz="2000" dirty="0"/>
+              <a:t>MIT 6.100L, lección 7: </a:t>
+            </a:r>
+            <a:r>
+              <a:rPr lang="es-MX" sz="2000" i="1" dirty="0" err="1"/>
+              <a:t>Decomposition</a:t>
+            </a:r>
+            <a:r>
+              <a:rPr lang="es-MX" sz="2000" i="1" dirty="0"/>
+              <a:t>, </a:t>
+            </a:r>
+            <a:r>
+              <a:rPr lang="es-MX" sz="2000" i="1" dirty="0" err="1"/>
+              <a:t>Abstraction</a:t>
+            </a:r>
+            <a:r>
+              <a:rPr lang="es-MX" sz="2000" i="1" dirty="0"/>
+              <a:t>, </a:t>
+            </a:r>
+            <a:r>
+              <a:rPr lang="es-MX" sz="2000" i="1" dirty="0" err="1"/>
+              <a:t>Functions</a:t>
+            </a:r>
+            <a:r>
+              <a:rPr lang="es-MX" sz="2000" dirty="0"/>
+              <a:t> (diapositivas)</a:t>
+            </a:r>
+            <a:br>
+              <a:rPr lang="es-MX" sz="2000" dirty="0"/>
+            </a:br>
+            <a:r>
+              <a:rPr lang="es-MX" sz="2000" dirty="0">
+                <a:hlinkClick r:id="rId5"/>
+              </a:rPr>
+              <a:t>https://ocw.mit.edu/courses/6-100l-introduction-to-cs-and-programming-using-python-fall-2022/resources/mit6_100l_f22_lec07_pdf/</a:t>
+            </a:r>
+            <a:endParaRPr lang="es-MX" sz="2000" dirty="0"/>
+          </a:p>
+          <a:p>
+            <a:pPr rtl="0">
+              <a:buFont typeface="Arial" panose="020B0604020202020204" pitchFamily="34" charset="0"/>
+              <a:buChar char="•"/>
+            </a:pPr>
+            <a:r>
+              <a:rPr lang="es-MX" sz="2000" dirty="0"/>
+              <a:t>MIT 6.100L, lección 7 (video)</a:t>
+            </a:r>
+            <a:br>
+              <a:rPr lang="es-MX" sz="2000" dirty="0"/>
+            </a:br>
+            <a:r>
+              <a:rPr lang="es-MX" sz="2000" dirty="0">
+                <a:hlinkClick r:id="rId6"/>
+              </a:rPr>
+              <a:t>https://ocw.mit.edu/courses/6-100l-introduction-to-cs-and-programming-using-python-fall-2022/resources/6100l-lecture-7-multi_mp4/</a:t>
+            </a:r>
+            <a:endParaRPr lang="es-MX" sz="2000" dirty="0"/>
+          </a:p>
+          <a:p>
+            <a:pPr rtl="0">
+              <a:buFont typeface="Arial" panose="020B0604020202020204" pitchFamily="34" charset="0"/>
+              <a:buChar char="•"/>
+            </a:pPr>
+            <a:r>
+              <a:rPr lang="es-MX" sz="2000" dirty="0"/>
+              <a:t>CS50P, lección 0: </a:t>
+            </a:r>
+            <a:r>
+              <a:rPr lang="es-MX" sz="2000" i="1" dirty="0" err="1"/>
+              <a:t>Functions</a:t>
+            </a:r>
+            <a:r>
+              <a:rPr lang="es-MX" sz="2000" i="1" dirty="0"/>
+              <a:t>, Variables</a:t>
+            </a:r>
+            <a:br>
+              <a:rPr lang="es-MX" sz="2000" dirty="0"/>
+            </a:br>
+            <a:r>
+              <a:rPr lang="es-MX" sz="2000" dirty="0">
+                <a:hlinkClick r:id="rId7"/>
+              </a:rPr>
+              <a:t>https://cs50.harvard.edu/python/notes/0/</a:t>
+            </a:r>
+            <a:endParaRPr lang="es-MX" sz="2000" dirty="0"/>
+          </a:p>
+          <a:p>
+            <a:pPr rtl="0"/>
+            <a:r>
+              <a:rPr lang="en-US" sz="2000" dirty="0"/>
+              <a:t>Liang, Y. D. </a:t>
+            </a:r>
+            <a:r>
+              <a:rPr lang="en-US" sz="2000" i="1" dirty="0"/>
+              <a:t>Introduction to Programming Using Python</a:t>
+            </a:r>
+            <a:r>
+              <a:rPr lang="en-US" sz="2000" dirty="0"/>
+              <a:t>, §6.13 </a:t>
+            </a:r>
+            <a:r>
+              <a:rPr lang="en-US" sz="2000" i="1" dirty="0"/>
+              <a:t>Function Abstraction and Stepwise Refinement</a:t>
+            </a:r>
+            <a:endParaRPr lang="es-MX" sz="2000" dirty="0"/>
+          </a:p>
+        </p:txBody>
+      </p:sp>
+    </p:spTree>
+    <p:extLst>
+      <p:ext uri="{BB962C8B-B14F-4D97-AF65-F5344CB8AC3E}">
+        <p14:creationId xmlns:p14="http://schemas.microsoft.com/office/powerpoint/2010/main" val="1023164851"/>
+      </p:ext>
+    </p:extLst>
+  </p:cSld>
+  <p:clrMapOvr>
+    <a:masterClrMapping/>
+  </p:clrMapOvr>
+</p:sld>
+</file>
+
+<file path=ppt/slides/slide35.xml><?xml version="1.0" encoding="utf-8"?>
+<p:sld xmlns:a="http://schemas.openxmlformats.org/drawingml/2006/main" xmlns:r="http://schemas.openxmlformats.org/officeDocument/2006/relationships" xmlns:p="http://schemas.openxmlformats.org/presentationml/2006/main">
+  <p:cSld>
+    <p:spTree>
+      <p:nvGrpSpPr>
+        <p:cNvPr id="1" name=""/>
+        <p:cNvGrpSpPr/>
+        <p:nvPr/>
+      </p:nvGrpSpPr>
+      <p:grpSpPr>
+        <a:xfrm>
+          <a:off x="0" y="0"/>
+          <a:ext cx="0" cy="0"/>
+          <a:chOff x="0" y="0"/>
+          <a:chExt cx="0" cy="0"/>
+        </a:xfrm>
+      </p:grpSpPr>
+      <p:sp>
+        <p:nvSpPr>
+          <p:cNvPr id="5" name="Title 4"/>
+          <p:cNvSpPr>
+            <a:spLocks noGrp="1"/>
+          </p:cNvSpPr>
+          <p:nvPr>
+            <p:ph type="title"/>
+          </p:nvPr>
+        </p:nvSpPr>
+        <p:spPr>
+          <a:xfrm>
+            <a:off x="107504" y="23817"/>
+            <a:ext cx="7886700" cy="812895"/>
+          </a:xfrm>
+        </p:spPr>
+        <p:txBody>
+          <a:bodyPr>
+            <a:normAutofit/>
+          </a:bodyPr>
+          <a:lstStyle/>
+          <a:p>
+            <a:r>
+              <a:rPr lang="en-US" sz="4000" dirty="0"/>
+              <a:t>Referencias</a:t>
+            </a:r>
+          </a:p>
+        </p:txBody>
+      </p:sp>
+      <p:sp>
+        <p:nvSpPr>
+          <p:cNvPr id="2" name="Content Placeholder 1"/>
+          <p:cNvSpPr>
+            <a:spLocks noGrp="1"/>
+          </p:cNvSpPr>
+          <p:nvPr>
+            <p:ph idx="1"/>
+          </p:nvPr>
+        </p:nvSpPr>
+        <p:spPr>
+          <a:xfrm>
+            <a:off x="251520" y="1088740"/>
+            <a:ext cx="8424936" cy="5148572"/>
+          </a:xfrm>
+        </p:spPr>
+        <p:txBody>
+          <a:bodyPr>
+            <a:normAutofit fontScale="92500" lnSpcReduction="10000"/>
+          </a:bodyPr>
+          <a:lstStyle/>
+          <a:p>
+            <a:pPr marL="457200" indent="-457200">
+              <a:buFont typeface="+mj-lt"/>
+              <a:buAutoNum type="arabicPeriod"/>
+            </a:pPr>
+            <a:r>
+              <a:rPr lang="es-CO" sz="2000" dirty="0">
+                <a:hlinkClick r:id="rId2"/>
+              </a:rPr>
+              <a:t>https://ellibrodepython.com/</a:t>
+            </a:r>
+            <a:endParaRPr lang="es-CO" sz="2000" dirty="0"/>
+          </a:p>
+          <a:p>
+            <a:pPr marL="457200" indent="-457200">
+              <a:buFont typeface="+mj-lt"/>
+              <a:buAutoNum type="arabicPeriod"/>
+            </a:pPr>
+            <a:r>
+              <a:rPr lang="es-CO" sz="2000" dirty="0">
+                <a:hlinkClick r:id="rId3"/>
+              </a:rPr>
+              <a:t>https://www.w3resource.com/index.php</a:t>
+            </a:r>
+            <a:endParaRPr lang="es-CO" sz="2000" dirty="0"/>
+          </a:p>
+          <a:p>
+            <a:pPr marL="457200" indent="-457200">
+              <a:buFont typeface="+mj-lt"/>
+              <a:buAutoNum type="arabicPeriod"/>
+            </a:pPr>
+            <a:r>
+              <a:rPr lang="es-CO" sz="2000" dirty="0">
+                <a:hlinkClick r:id="rId4"/>
+              </a:rPr>
+              <a:t>https://realpython.com/</a:t>
+            </a:r>
+            <a:endParaRPr lang="es-CO" sz="2000" dirty="0"/>
+          </a:p>
+          <a:p>
+            <a:pPr marL="457200" indent="-457200">
+              <a:buFont typeface="+mj-lt"/>
+              <a:buAutoNum type="arabicPeriod"/>
+            </a:pPr>
+            <a:r>
+              <a:rPr lang="es-CO" sz="2000" dirty="0">
+                <a:hlinkClick r:id="rId5"/>
+              </a:rPr>
+              <a:t>https://curriculumresources.edu.gh/wp-content/uploads/2025/01/</a:t>
+            </a:r>
+            <a:endParaRPr lang="es-CO" sz="2000" dirty="0"/>
+          </a:p>
+          <a:p>
+            <a:pPr marL="457200" indent="-457200">
+              <a:buFont typeface="+mj-lt"/>
+              <a:buAutoNum type="arabicPeriod"/>
+            </a:pPr>
+            <a:r>
+              <a:rPr lang="es-CO" sz="2000" dirty="0">
+                <a:hlinkClick r:id="rId6"/>
+              </a:rPr>
+              <a:t>https://python-course.eu/</a:t>
+            </a:r>
+            <a:endParaRPr lang="es-CO" sz="2000" dirty="0"/>
+          </a:p>
+          <a:p>
+            <a:pPr marL="457200" indent="-457200">
+              <a:buFont typeface="+mj-lt"/>
+              <a:buAutoNum type="arabicPeriod"/>
+            </a:pPr>
+            <a:r>
+              <a:rPr lang="es-CO" sz="2000" dirty="0">
+                <a:hlinkClick r:id="rId7"/>
+              </a:rPr>
+              <a:t>https://realpython.com/cheatsheets/python/</a:t>
+            </a:r>
+            <a:endParaRPr lang="es-CO" sz="2000" dirty="0"/>
+          </a:p>
+          <a:p>
+            <a:pPr marL="457200" indent="-457200">
+              <a:buFont typeface="+mj-lt"/>
+              <a:buAutoNum type="arabicPeriod"/>
+            </a:pPr>
+            <a:r>
+              <a:rPr lang="es-CO" sz="2000" dirty="0">
+                <a:hlinkClick r:id="rId8"/>
+              </a:rPr>
+              <a:t>https://realpython.com/defining-your-own-python-function/</a:t>
+            </a:r>
+            <a:r>
+              <a:rPr lang="es-CO" sz="2000" dirty="0"/>
+              <a:t>    </a:t>
+            </a:r>
+          </a:p>
+          <a:p>
+            <a:pPr marL="457200" indent="-457200">
+              <a:buFont typeface="+mj-lt"/>
+              <a:buAutoNum type="arabicPeriod"/>
+            </a:pPr>
+            <a:r>
+              <a:rPr lang="es-CO" sz="2000" dirty="0">
+                <a:hlinkClick r:id="rId9"/>
+              </a:rPr>
+              <a:t>https://realpython.com/python-built-in-functions/</a:t>
+            </a:r>
+            <a:endParaRPr lang="es-CO" sz="2000" dirty="0"/>
+          </a:p>
+          <a:p>
+            <a:pPr marL="457200" indent="-457200">
+              <a:buFont typeface="+mj-lt"/>
+              <a:buAutoNum type="arabicPeriod"/>
+            </a:pPr>
+            <a:r>
+              <a:rPr lang="es-CO" sz="2000" dirty="0">
+                <a:hlinkClick r:id="rId10"/>
+              </a:rPr>
+              <a:t>https://realpython.com/ref/best-practices/functions/</a:t>
+            </a:r>
+            <a:r>
+              <a:rPr lang="es-CO" sz="2000" dirty="0"/>
+              <a:t> </a:t>
+            </a:r>
+          </a:p>
+          <a:p>
+            <a:pPr marL="457200" indent="-457200">
+              <a:buFont typeface="+mj-lt"/>
+              <a:buAutoNum type="arabicPeriod"/>
+            </a:pPr>
+            <a:r>
+              <a:rPr lang="es-CO" sz="2000" dirty="0">
+                <a:hlinkClick r:id="rId11"/>
+              </a:rPr>
+              <a:t>https://makecode.microbit.org/courses/csintro</a:t>
+            </a:r>
+            <a:r>
+              <a:rPr lang="es-CO" sz="2000" dirty="0"/>
+              <a:t>   </a:t>
+            </a:r>
+          </a:p>
+          <a:p>
+            <a:pPr marL="457200" indent="-457200">
+              <a:buFont typeface="+mj-lt"/>
+              <a:buAutoNum type="arabicPeriod"/>
+            </a:pPr>
+            <a:r>
+              <a:rPr lang="en-US" sz="2000" dirty="0">
+                <a:hlinkClick r:id="rId12"/>
+              </a:rPr>
+              <a:t>https://makecode.microbit.org/courses</a:t>
+            </a:r>
+            <a:r>
+              <a:rPr lang="en-US" sz="2000" dirty="0"/>
+              <a:t> </a:t>
+            </a:r>
+          </a:p>
+          <a:p>
+            <a:pPr marL="457200" indent="-457200">
+              <a:buFont typeface="+mj-lt"/>
+              <a:buAutoNum type="arabicPeriod"/>
+            </a:pPr>
+            <a:r>
+              <a:rPr lang="en-US" sz="2000" dirty="0">
+                <a:hlinkClick r:id="rId13"/>
+              </a:rPr>
+              <a:t>https://realpython.com/python-while-loop/</a:t>
+            </a:r>
+            <a:endParaRPr lang="en-US" sz="2000" dirty="0"/>
+          </a:p>
+          <a:p>
+            <a:pPr marL="457200" indent="-457200">
+              <a:buFont typeface="+mj-lt"/>
+              <a:buAutoNum type="arabicPeriod"/>
+            </a:pPr>
+            <a:r>
+              <a:rPr lang="en-US" sz="2000" dirty="0">
+                <a:hlinkClick r:id="rId14"/>
+              </a:rPr>
+              <a:t>https://realpython.com/ref/keywords/while/</a:t>
+            </a:r>
+            <a:r>
+              <a:rPr lang="en-US" sz="2000" dirty="0"/>
+              <a:t> </a:t>
+            </a:r>
+          </a:p>
+          <a:p>
+            <a:pPr marL="457200" indent="-457200">
+              <a:buFont typeface="+mj-lt"/>
+              <a:buAutoNum type="arabicPeriod"/>
+            </a:pPr>
+            <a:r>
+              <a:rPr lang="en-US" sz="2000" dirty="0">
+                <a:hlinkClick r:id="rId15"/>
+              </a:rPr>
+              <a:t>https://cs.stanford.edu/people/nick/py/</a:t>
+            </a:r>
+            <a:r>
+              <a:rPr lang="en-US" sz="2000" dirty="0"/>
+              <a:t> </a:t>
+            </a:r>
+          </a:p>
+        </p:txBody>
+      </p:sp>
+    </p:spTree>
+    <p:extLst>
+      <p:ext uri="{BB962C8B-B14F-4D97-AF65-F5344CB8AC3E}">
+        <p14:creationId xmlns:p14="http://schemas.microsoft.com/office/powerpoint/2010/main" val="568862748"/>
+      </p:ext>
+    </p:extLst>
+  </p:cSld>
+  <p:clrMapOvr>
+    <a:masterClrMapping/>
+  </p:clrMapOvr>
+</p:sld>
+</file>
+
+<file path=ppt/slides/slide36.xml><?xml version="1.0" encoding="utf-8"?>
+<p:sld xmlns:a="http://schemas.openxmlformats.org/drawingml/2006/main" xmlns:r="http://schemas.openxmlformats.org/officeDocument/2006/relationships" xmlns:p="http://schemas.openxmlformats.org/presentationml/2006/main">
+  <p:cSld>
+    <p:spTree>
+      <p:nvGrpSpPr>
+        <p:cNvPr id="1" name=""/>
+        <p:cNvGrpSpPr/>
+        <p:nvPr/>
+      </p:nvGrpSpPr>
+      <p:grpSpPr>
+        <a:xfrm>
+          <a:off x="0" y="0"/>
+          <a:ext cx="0" cy="0"/>
+          <a:chOff x="0" y="0"/>
+          <a:chExt cx="0" cy="0"/>
+        </a:xfrm>
+      </p:grpSpPr>
+      <p:sp>
+        <p:nvSpPr>
+          <p:cNvPr id="2" name="Title 1"/>
+          <p:cNvSpPr>
+            <a:spLocks noGrp="1"/>
+          </p:cNvSpPr>
+          <p:nvPr>
+            <p:ph type="title"/>
+          </p:nvPr>
+        </p:nvSpPr>
+        <p:spPr>
+          <a:xfrm>
+            <a:off x="323528" y="180617"/>
+            <a:ext cx="8191822" cy="728103"/>
+          </a:xfrm>
+        </p:spPr>
+        <p:txBody>
+          <a:bodyPr/>
+          <a:lstStyle/>
+          <a:p>
+            <a:r>
+              <a:rPr lang="es-CO" dirty="0"/>
+              <a:t>Eso es todo amigos</a:t>
+            </a:r>
+            <a:endParaRPr lang="en-US" dirty="0"/>
+          </a:p>
+        </p:txBody>
+      </p:sp>
+      <p:pic>
+        <p:nvPicPr>
+          <p:cNvPr id="4" name="Picture 4">
+            <a:extLst>
+              <a:ext uri="{FF2B5EF4-FFF2-40B4-BE49-F238E27FC236}">
+                <a16:creationId xmlns:a16="http://schemas.microsoft.com/office/drawing/2014/main" id="{7F35EEF4-F126-467F-A5BB-259AA64991BD}"/>
+              </a:ext>
+            </a:extLst>
+          </p:cNvPr>
+          <p:cNvPicPr>
+            <a:picLocks noChangeAspect="1" noChangeArrowheads="1"/>
+          </p:cNvPicPr>
+          <p:nvPr/>
+        </p:nvPicPr>
+        <p:blipFill>
+          <a:blip r:embed="rId2">
+            <a:extLst>
+              <a:ext uri="{28A0092B-C50C-407E-A947-70E740481C1C}">
+                <a14:useLocalDpi xmlns:a14="http://schemas.microsoft.com/office/drawing/2010/main" val="0"/>
+              </a:ext>
+            </a:extLst>
+          </a:blip>
+          <a:srcRect/>
+          <a:stretch>
+            <a:fillRect/>
+          </a:stretch>
+        </p:blipFill>
+        <p:spPr bwMode="auto">
+          <a:xfrm>
+            <a:off x="4211960" y="912200"/>
+            <a:ext cx="4113633" cy="5868856"/>
+          </a:xfrm>
+          <a:prstGeom prst="rect">
+            <a:avLst/>
+          </a:prstGeom>
+          <a:noFill/>
+          <a:extLst>
+            <a:ext uri="{909E8E84-426E-40DD-AFC4-6F175D3DCCD1}">
+              <a14:hiddenFill xmlns:a14="http://schemas.microsoft.com/office/drawing/2010/main">
+                <a:solidFill>
+                  <a:srgbClr val="FFFFFF"/>
+                </a:solidFill>
+              </a14:hiddenFill>
+            </a:ext>
+          </a:extLst>
+        </p:spPr>
+      </p:pic>
+      <p:sp>
+        <p:nvSpPr>
+          <p:cNvPr id="5" name="7 Rectángulo">
+            <a:extLst>
+              <a:ext uri="{FF2B5EF4-FFF2-40B4-BE49-F238E27FC236}">
+                <a16:creationId xmlns:a16="http://schemas.microsoft.com/office/drawing/2014/main" id="{27C7AA4C-274E-4F17-B614-41C209AA98D3}"/>
+              </a:ext>
+            </a:extLst>
+          </p:cNvPr>
+          <p:cNvSpPr/>
+          <p:nvPr/>
+        </p:nvSpPr>
+        <p:spPr>
+          <a:xfrm>
+            <a:off x="101021" y="6519446"/>
+            <a:ext cx="3678892" cy="261610"/>
+          </a:xfrm>
+          <a:prstGeom prst="rect">
+            <a:avLst/>
+          </a:prstGeom>
+        </p:spPr>
+        <p:txBody>
+          <a:bodyPr wrap="square">
+            <a:spAutoFit/>
+          </a:bodyPr>
+          <a:lstStyle/>
+          <a:p>
+            <a:r>
+              <a:rPr lang="es-CO" sz="1100" dirty="0">
+                <a:hlinkClick r:id="rId3"/>
+              </a:rPr>
+              <a:t>https://phdcomics.com/comics/archive.php?comicid=1431</a:t>
+            </a:r>
+            <a:r>
+              <a:rPr lang="es-CO" sz="1100" dirty="0"/>
+              <a:t> </a:t>
+            </a:r>
+          </a:p>
+        </p:txBody>
+      </p:sp>
+      <p:pic>
+        <p:nvPicPr>
+          <p:cNvPr id="2050" name="Picture 2" descr="Ouch Images – Browse 81,244 Stock Photos, Vectors, and Video | Adobe Stock">
+            <a:extLst>
+              <a:ext uri="{FF2B5EF4-FFF2-40B4-BE49-F238E27FC236}">
+                <a16:creationId xmlns:a16="http://schemas.microsoft.com/office/drawing/2014/main" id="{190AEE93-FCB4-45D0-A740-34697C5E7782}"/>
+              </a:ext>
+            </a:extLst>
+          </p:cNvPr>
+          <p:cNvPicPr>
+            <a:picLocks noChangeAspect="1" noChangeArrowheads="1"/>
+          </p:cNvPicPr>
+          <p:nvPr/>
+        </p:nvPicPr>
+        <p:blipFill>
+          <a:blip r:embed="rId4">
+            <a:extLst>
+              <a:ext uri="{28A0092B-C50C-407E-A947-70E740481C1C}">
+                <a14:useLocalDpi xmlns:a14="http://schemas.microsoft.com/office/drawing/2010/main" val="0"/>
+              </a:ext>
+            </a:extLst>
+          </a:blip>
+          <a:srcRect/>
+          <a:stretch>
+            <a:fillRect/>
+          </a:stretch>
+        </p:blipFill>
+        <p:spPr bwMode="auto">
+          <a:xfrm>
+            <a:off x="297451" y="2496793"/>
+            <a:ext cx="3563955" cy="2434580"/>
+          </a:xfrm>
+          <a:prstGeom prst="rect">
+            <a:avLst/>
+          </a:prstGeom>
+          <a:noFill/>
+          <a:extLst>
+            <a:ext uri="{909E8E84-426E-40DD-AFC4-6F175D3DCCD1}">
+              <a14:hiddenFill xmlns:a14="http://schemas.microsoft.com/office/drawing/2010/main">
+                <a:solidFill>
+                  <a:srgbClr val="FFFFFF"/>
+                </a:solidFill>
+              </a14:hiddenFill>
+            </a:ext>
+          </a:extLst>
+        </p:spPr>
+      </p:pic>
+    </p:spTree>
+    <p:extLst>
+      <p:ext uri="{BB962C8B-B14F-4D97-AF65-F5344CB8AC3E}">
+        <p14:creationId xmlns:p14="http://schemas.microsoft.com/office/powerpoint/2010/main" val="3024962735"/>
       </p:ext>
     </p:extLst>
   </p:cSld>

</xml_diff>